<commit_message>
Include latest proposal presentations
</commit_message>
<xml_diff>
--- a/proposals/low_overlap_registration_proposal.pptx
+++ b/proposals/low_overlap_registration_proposal.pptx
@@ -195,7 +195,7 @@
             </a:lvl1pPr>
           </a:lstStyle>
           <a:p>
-            <a:fld id="{AAEF90E1-A1F2-4202-8311-C8CFB46FF44C}" type="datetimeFigureOut">
+            <a:fld id="{B7170C6B-907A-4C1F-8A30-E2685AC5AE07}" type="datetimeFigureOut">
               <a:rPr lang="zh-CN" altLang="en-US" smtClean="0"/>
               <a:t>2026/10/16</a:t>
             </a:fld>
@@ -353,7 +353,7 @@
             </a:lvl1pPr>
           </a:lstStyle>
           <a:p>
-            <a:fld id="{F723AF69-189D-4F4A-915E-82AB2F08FD73}" type="slidenum">
+            <a:fld id="{54673AAE-F065-42A0-9982-73C7F44EE74C}" type="slidenum">
               <a:rPr lang="zh-CN" altLang="en-US" smtClean="0"/>
               <a:t>‹#›</a:t>
             </a:fld>
@@ -364,7 +364,7 @@
     </p:spTree>
     <p:extLst>
       <p:ext uri="{BB962C8B-B14F-4D97-AF65-F5344CB8AC3E}">
-        <p14:creationId xmlns:p14="http://schemas.microsoft.com/office/powerpoint/2010/main" val="1027134899"/>
+        <p14:creationId xmlns:p14="http://schemas.microsoft.com/office/powerpoint/2010/main" val="3270356866"/>
       </p:ext>
     </p:extLst>
   </p:cSld>
@@ -924,7 +924,7 @@
           <a:bodyPr/>
           <a:lstStyle/>
           <a:p>
-            <a:fld id="{F723AF69-189D-4F4A-915E-82AB2F08FD73}" type="slidenum">
+            <a:fld id="{54673AAE-F065-42A0-9982-73C7F44EE74C}" type="slidenum">
               <a:rPr lang="zh-CN" altLang="en-US" smtClean="0"/>
               <a:t>1</a:t>
             </a:fld>
@@ -935,7 +935,7 @@
     </p:spTree>
     <p:extLst>
       <p:ext uri="{BB962C8B-B14F-4D97-AF65-F5344CB8AC3E}">
-        <p14:creationId xmlns:p14="http://schemas.microsoft.com/office/powerpoint/2010/main" val="2529903665"/>
+        <p14:creationId xmlns:p14="http://schemas.microsoft.com/office/powerpoint/2010/main" val="3485130513"/>
       </p:ext>
     </p:extLst>
   </p:cSld>
@@ -1326,7 +1326,7 @@
           <a:bodyPr/>
           <a:lstStyle/>
           <a:p>
-            <a:fld id="{F723AF69-189D-4F4A-915E-82AB2F08FD73}" type="slidenum">
+            <a:fld id="{54673AAE-F065-42A0-9982-73C7F44EE74C}" type="slidenum">
               <a:rPr lang="zh-CN" altLang="en-US" smtClean="0"/>
               <a:t>2</a:t>
             </a:fld>
@@ -1337,7 +1337,7 @@
     </p:spTree>
     <p:extLst>
       <p:ext uri="{BB962C8B-B14F-4D97-AF65-F5344CB8AC3E}">
-        <p14:creationId xmlns:p14="http://schemas.microsoft.com/office/powerpoint/2010/main" val="1832649029"/>
+        <p14:creationId xmlns:p14="http://schemas.microsoft.com/office/powerpoint/2010/main" val="277608268"/>
       </p:ext>
     </p:extLst>
   </p:cSld>
@@ -1658,7 +1658,7 @@
           <a:bodyPr/>
           <a:lstStyle/>
           <a:p>
-            <a:fld id="{F723AF69-189D-4F4A-915E-82AB2F08FD73}" type="slidenum">
+            <a:fld id="{54673AAE-F065-42A0-9982-73C7F44EE74C}" type="slidenum">
               <a:rPr lang="zh-CN" altLang="en-US" smtClean="0"/>
               <a:t>3</a:t>
             </a:fld>
@@ -1669,7 +1669,7 @@
     </p:spTree>
     <p:extLst>
       <p:ext uri="{BB962C8B-B14F-4D97-AF65-F5344CB8AC3E}">
-        <p14:creationId xmlns:p14="http://schemas.microsoft.com/office/powerpoint/2010/main" val="476003004"/>
+        <p14:creationId xmlns:p14="http://schemas.microsoft.com/office/powerpoint/2010/main" val="2414952060"/>
       </p:ext>
     </p:extLst>
   </p:cSld>
@@ -2258,7 +2258,7 @@
           <a:bodyPr/>
           <a:lstStyle/>
           <a:p>
-            <a:fld id="{F723AF69-189D-4F4A-915E-82AB2F08FD73}" type="slidenum">
+            <a:fld id="{54673AAE-F065-42A0-9982-73C7F44EE74C}" type="slidenum">
               <a:rPr lang="zh-CN" altLang="en-US" smtClean="0"/>
               <a:t>4</a:t>
             </a:fld>
@@ -2269,7 +2269,7 @@
     </p:spTree>
     <p:extLst>
       <p:ext uri="{BB962C8B-B14F-4D97-AF65-F5344CB8AC3E}">
-        <p14:creationId xmlns:p14="http://schemas.microsoft.com/office/powerpoint/2010/main" val="3329528462"/>
+        <p14:creationId xmlns:p14="http://schemas.microsoft.com/office/powerpoint/2010/main" val="3952281756"/>
       </p:ext>
     </p:extLst>
   </p:cSld>
@@ -2774,7 +2774,7 @@
           <a:bodyPr/>
           <a:lstStyle/>
           <a:p>
-            <a:fld id="{F723AF69-189D-4F4A-915E-82AB2F08FD73}" type="slidenum">
+            <a:fld id="{54673AAE-F065-42A0-9982-73C7F44EE74C}" type="slidenum">
               <a:rPr lang="zh-CN" altLang="en-US" smtClean="0"/>
               <a:t>5</a:t>
             </a:fld>
@@ -2785,7 +2785,7 @@
     </p:spTree>
     <p:extLst>
       <p:ext uri="{BB962C8B-B14F-4D97-AF65-F5344CB8AC3E}">
-        <p14:creationId xmlns:p14="http://schemas.microsoft.com/office/powerpoint/2010/main" val="2250030008"/>
+        <p14:creationId xmlns:p14="http://schemas.microsoft.com/office/powerpoint/2010/main" val="2249867179"/>
       </p:ext>
     </p:extLst>
   </p:cSld>
@@ -2983,7 +2983,7 @@
           <a:bodyPr/>
           <a:lstStyle/>
           <a:p>
-            <a:fld id="{F723AF69-189D-4F4A-915E-82AB2F08FD73}" type="slidenum">
+            <a:fld id="{54673AAE-F065-42A0-9982-73C7F44EE74C}" type="slidenum">
               <a:rPr lang="zh-CN" altLang="en-US" smtClean="0"/>
               <a:t>6</a:t>
             </a:fld>
@@ -2994,7 +2994,7 @@
     </p:spTree>
     <p:extLst>
       <p:ext uri="{BB962C8B-B14F-4D97-AF65-F5344CB8AC3E}">
-        <p14:creationId xmlns:p14="http://schemas.microsoft.com/office/powerpoint/2010/main" val="4278184093"/>
+        <p14:creationId xmlns:p14="http://schemas.microsoft.com/office/powerpoint/2010/main" val="2846916716"/>
       </p:ext>
     </p:extLst>
   </p:cSld>
@@ -3026,7 +3026,7 @@
           <p:cNvPr id="2" name="标题 1">
             <a:extLst>
               <a:ext uri="{FF2B5EF4-FFF2-40B4-BE49-F238E27FC236}">
-                <a16:creationId xmlns:a16="http://schemas.microsoft.com/office/drawing/2014/main" id="{BBE2E5BC-876A-E1AA-63D4-ED188C5D46E4}"/>
+                <a16:creationId xmlns:a16="http://schemas.microsoft.com/office/drawing/2014/main" id="{82FD15E5-FD8B-C6B7-E53A-F49D8DC02177}"/>
               </a:ext>
             </a:extLst>
           </p:cNvPr>
@@ -3063,7 +3063,7 @@
           <p:cNvPr id="3" name="副标题 2">
             <a:extLst>
               <a:ext uri="{FF2B5EF4-FFF2-40B4-BE49-F238E27FC236}">
-                <a16:creationId xmlns:a16="http://schemas.microsoft.com/office/drawing/2014/main" id="{011F7A36-FAAC-0CBD-A1B4-F2839266DC6C}"/>
+                <a16:creationId xmlns:a16="http://schemas.microsoft.com/office/drawing/2014/main" id="{6474EA0C-A646-8F26-7F8B-6BB8FCC17AE3}"/>
               </a:ext>
             </a:extLst>
           </p:cNvPr>
@@ -3133,7 +3133,7 @@
           <p:cNvPr id="4" name="日期占位符 3">
             <a:extLst>
               <a:ext uri="{FF2B5EF4-FFF2-40B4-BE49-F238E27FC236}">
-                <a16:creationId xmlns:a16="http://schemas.microsoft.com/office/drawing/2014/main" id="{2EDC64A9-1167-FF2D-1E0A-9A12C5E9FF51}"/>
+                <a16:creationId xmlns:a16="http://schemas.microsoft.com/office/drawing/2014/main" id="{DB9A5098-5F07-7181-BEA8-11BE61D63EBF}"/>
               </a:ext>
             </a:extLst>
           </p:cNvPr>
@@ -3149,7 +3149,7 @@
           <a:bodyPr/>
           <a:lstStyle/>
           <a:p>
-            <a:fld id="{12CCD2F0-1229-427F-8DED-D4160314B5FF}" type="datetimeFigureOut">
+            <a:fld id="{46AEA13A-38A6-4884-A297-BE05C8B99F63}" type="datetimeFigureOut">
               <a:rPr lang="zh-CN" altLang="en-US" smtClean="0"/>
               <a:t>2026/10/16</a:t>
             </a:fld>
@@ -3162,7 +3162,7 @@
           <p:cNvPr id="5" name="页脚占位符 4">
             <a:extLst>
               <a:ext uri="{FF2B5EF4-FFF2-40B4-BE49-F238E27FC236}">
-                <a16:creationId xmlns:a16="http://schemas.microsoft.com/office/drawing/2014/main" id="{D8571B82-E336-BD8B-92D3-4B464B245A13}"/>
+                <a16:creationId xmlns:a16="http://schemas.microsoft.com/office/drawing/2014/main" id="{B131B19F-72A7-F6B1-496B-CDCF9BCEB0D1}"/>
               </a:ext>
             </a:extLst>
           </p:cNvPr>
@@ -3187,7 +3187,7 @@
           <p:cNvPr id="6" name="灯片编号占位符 5">
             <a:extLst>
               <a:ext uri="{FF2B5EF4-FFF2-40B4-BE49-F238E27FC236}">
-                <a16:creationId xmlns:a16="http://schemas.microsoft.com/office/drawing/2014/main" id="{C29ABEFC-20E5-B3C4-4D82-731C9DDE4019}"/>
+                <a16:creationId xmlns:a16="http://schemas.microsoft.com/office/drawing/2014/main" id="{BA9D9FB2-F227-69B2-D222-98F78F99F45A}"/>
               </a:ext>
             </a:extLst>
           </p:cNvPr>
@@ -3203,7 +3203,7 @@
           <a:bodyPr/>
           <a:lstStyle/>
           <a:p>
-            <a:fld id="{84077ECE-D770-4FDA-A17E-E75B8EA1220F}" type="slidenum">
+            <a:fld id="{B165BA6E-6F74-4E19-BCC8-1D3F5CECF083}" type="slidenum">
               <a:rPr lang="zh-CN" altLang="en-US" smtClean="0"/>
               <a:t>‹#›</a:t>
             </a:fld>
@@ -3214,7 +3214,7 @@
     </p:spTree>
     <p:extLst>
       <p:ext uri="{BB962C8B-B14F-4D97-AF65-F5344CB8AC3E}">
-        <p14:creationId xmlns:p14="http://schemas.microsoft.com/office/powerpoint/2010/main" val="3649829895"/>
+        <p14:creationId xmlns:p14="http://schemas.microsoft.com/office/powerpoint/2010/main" val="2946069881"/>
       </p:ext>
     </p:extLst>
   </p:cSld>
@@ -3246,7 +3246,7 @@
           <p:cNvPr id="2" name="标题 1">
             <a:extLst>
               <a:ext uri="{FF2B5EF4-FFF2-40B4-BE49-F238E27FC236}">
-                <a16:creationId xmlns:a16="http://schemas.microsoft.com/office/drawing/2014/main" id="{879ECF45-6F94-AD99-CB81-61095DD61B61}"/>
+                <a16:creationId xmlns:a16="http://schemas.microsoft.com/office/drawing/2014/main" id="{A7372847-3B73-7CB9-8798-29E2E34A6CBE}"/>
               </a:ext>
             </a:extLst>
           </p:cNvPr>
@@ -3274,7 +3274,7 @@
           <p:cNvPr id="3" name="竖排文字占位符 2">
             <a:extLst>
               <a:ext uri="{FF2B5EF4-FFF2-40B4-BE49-F238E27FC236}">
-                <a16:creationId xmlns:a16="http://schemas.microsoft.com/office/drawing/2014/main" id="{DAE08F4B-D439-1AE0-B60E-DB22FE80DF42}"/>
+                <a16:creationId xmlns:a16="http://schemas.microsoft.com/office/drawing/2014/main" id="{7BE9150D-FAA9-DD9F-0D0B-B0174E148187}"/>
               </a:ext>
             </a:extLst>
           </p:cNvPr>
@@ -3331,7 +3331,7 @@
           <p:cNvPr id="4" name="日期占位符 3">
             <a:extLst>
               <a:ext uri="{FF2B5EF4-FFF2-40B4-BE49-F238E27FC236}">
-                <a16:creationId xmlns:a16="http://schemas.microsoft.com/office/drawing/2014/main" id="{E088D176-A58B-4F1C-2982-BF498FD8246F}"/>
+                <a16:creationId xmlns:a16="http://schemas.microsoft.com/office/drawing/2014/main" id="{EE5F47DA-8FB2-A373-5DFB-99B59C1220E1}"/>
               </a:ext>
             </a:extLst>
           </p:cNvPr>
@@ -3347,7 +3347,7 @@
           <a:bodyPr/>
           <a:lstStyle/>
           <a:p>
-            <a:fld id="{12CCD2F0-1229-427F-8DED-D4160314B5FF}" type="datetimeFigureOut">
+            <a:fld id="{46AEA13A-38A6-4884-A297-BE05C8B99F63}" type="datetimeFigureOut">
               <a:rPr lang="zh-CN" altLang="en-US" smtClean="0"/>
               <a:t>2026/10/16</a:t>
             </a:fld>
@@ -3360,7 +3360,7 @@
           <p:cNvPr id="5" name="页脚占位符 4">
             <a:extLst>
               <a:ext uri="{FF2B5EF4-FFF2-40B4-BE49-F238E27FC236}">
-                <a16:creationId xmlns:a16="http://schemas.microsoft.com/office/drawing/2014/main" id="{0EEE2C98-EC63-2001-C571-03913AF3A3E0}"/>
+                <a16:creationId xmlns:a16="http://schemas.microsoft.com/office/drawing/2014/main" id="{7C5DE71B-947A-8F27-39BE-76211F617D9E}"/>
               </a:ext>
             </a:extLst>
           </p:cNvPr>
@@ -3385,7 +3385,7 @@
           <p:cNvPr id="6" name="灯片编号占位符 5">
             <a:extLst>
               <a:ext uri="{FF2B5EF4-FFF2-40B4-BE49-F238E27FC236}">
-                <a16:creationId xmlns:a16="http://schemas.microsoft.com/office/drawing/2014/main" id="{497EB3FC-2033-6F25-87D6-232D1A629E8D}"/>
+                <a16:creationId xmlns:a16="http://schemas.microsoft.com/office/drawing/2014/main" id="{BB8D1E45-6913-AF94-9974-DECE0B92C80F}"/>
               </a:ext>
             </a:extLst>
           </p:cNvPr>
@@ -3401,7 +3401,7 @@
           <a:bodyPr/>
           <a:lstStyle/>
           <a:p>
-            <a:fld id="{84077ECE-D770-4FDA-A17E-E75B8EA1220F}" type="slidenum">
+            <a:fld id="{B165BA6E-6F74-4E19-BCC8-1D3F5CECF083}" type="slidenum">
               <a:rPr lang="zh-CN" altLang="en-US" smtClean="0"/>
               <a:t>‹#›</a:t>
             </a:fld>
@@ -3412,7 +3412,7 @@
     </p:spTree>
     <p:extLst>
       <p:ext uri="{BB962C8B-B14F-4D97-AF65-F5344CB8AC3E}">
-        <p14:creationId xmlns:p14="http://schemas.microsoft.com/office/powerpoint/2010/main" val="3434886007"/>
+        <p14:creationId xmlns:p14="http://schemas.microsoft.com/office/powerpoint/2010/main" val="666299271"/>
       </p:ext>
     </p:extLst>
   </p:cSld>
@@ -3444,7 +3444,7 @@
           <p:cNvPr id="2" name="竖排标题 1">
             <a:extLst>
               <a:ext uri="{FF2B5EF4-FFF2-40B4-BE49-F238E27FC236}">
-                <a16:creationId xmlns:a16="http://schemas.microsoft.com/office/drawing/2014/main" id="{F3A82F67-C4CE-2E93-ACBF-BABBD686823A}"/>
+                <a16:creationId xmlns:a16="http://schemas.microsoft.com/office/drawing/2014/main" id="{9065429C-0C0A-C4F2-CA7A-7AC9F260D01E}"/>
               </a:ext>
             </a:extLst>
           </p:cNvPr>
@@ -3477,7 +3477,7 @@
           <p:cNvPr id="3" name="竖排文字占位符 2">
             <a:extLst>
               <a:ext uri="{FF2B5EF4-FFF2-40B4-BE49-F238E27FC236}">
-                <a16:creationId xmlns:a16="http://schemas.microsoft.com/office/drawing/2014/main" id="{A0856703-1CC3-754E-5A1E-180317E7B240}"/>
+                <a16:creationId xmlns:a16="http://schemas.microsoft.com/office/drawing/2014/main" id="{0E7DF4B8-4B9B-E25B-7195-DB9312DB1540}"/>
               </a:ext>
             </a:extLst>
           </p:cNvPr>
@@ -3539,7 +3539,7 @@
           <p:cNvPr id="4" name="日期占位符 3">
             <a:extLst>
               <a:ext uri="{FF2B5EF4-FFF2-40B4-BE49-F238E27FC236}">
-                <a16:creationId xmlns:a16="http://schemas.microsoft.com/office/drawing/2014/main" id="{1FE28BA7-A3E1-6C29-E379-77A80CE802A1}"/>
+                <a16:creationId xmlns:a16="http://schemas.microsoft.com/office/drawing/2014/main" id="{3802C822-6A61-D51D-8177-63F1EF8351AD}"/>
               </a:ext>
             </a:extLst>
           </p:cNvPr>
@@ -3555,7 +3555,7 @@
           <a:bodyPr/>
           <a:lstStyle/>
           <a:p>
-            <a:fld id="{12CCD2F0-1229-427F-8DED-D4160314B5FF}" type="datetimeFigureOut">
+            <a:fld id="{46AEA13A-38A6-4884-A297-BE05C8B99F63}" type="datetimeFigureOut">
               <a:rPr lang="zh-CN" altLang="en-US" smtClean="0"/>
               <a:t>2026/10/16</a:t>
             </a:fld>
@@ -3568,7 +3568,7 @@
           <p:cNvPr id="5" name="页脚占位符 4">
             <a:extLst>
               <a:ext uri="{FF2B5EF4-FFF2-40B4-BE49-F238E27FC236}">
-                <a16:creationId xmlns:a16="http://schemas.microsoft.com/office/drawing/2014/main" id="{1ACA1827-A350-74D2-05A5-D530C75D8202}"/>
+                <a16:creationId xmlns:a16="http://schemas.microsoft.com/office/drawing/2014/main" id="{0B7F3D48-02D3-5144-C85C-C2A15B5C2C54}"/>
               </a:ext>
             </a:extLst>
           </p:cNvPr>
@@ -3593,7 +3593,7 @@
           <p:cNvPr id="6" name="灯片编号占位符 5">
             <a:extLst>
               <a:ext uri="{FF2B5EF4-FFF2-40B4-BE49-F238E27FC236}">
-                <a16:creationId xmlns:a16="http://schemas.microsoft.com/office/drawing/2014/main" id="{BCA171B8-A3E9-5920-7C78-28E2E6A79C04}"/>
+                <a16:creationId xmlns:a16="http://schemas.microsoft.com/office/drawing/2014/main" id="{1923BB2C-DCF6-3F5D-4E8F-6E54C6CB200E}"/>
               </a:ext>
             </a:extLst>
           </p:cNvPr>
@@ -3609,7 +3609,7 @@
           <a:bodyPr/>
           <a:lstStyle/>
           <a:p>
-            <a:fld id="{84077ECE-D770-4FDA-A17E-E75B8EA1220F}" type="slidenum">
+            <a:fld id="{B165BA6E-6F74-4E19-BCC8-1D3F5CECF083}" type="slidenum">
               <a:rPr lang="zh-CN" altLang="en-US" smtClean="0"/>
               <a:t>‹#›</a:t>
             </a:fld>
@@ -3620,7 +3620,7 @@
     </p:spTree>
     <p:extLst>
       <p:ext uri="{BB962C8B-B14F-4D97-AF65-F5344CB8AC3E}">
-        <p14:creationId xmlns:p14="http://schemas.microsoft.com/office/powerpoint/2010/main" val="2547505839"/>
+        <p14:creationId xmlns:p14="http://schemas.microsoft.com/office/powerpoint/2010/main" val="2633650103"/>
       </p:ext>
     </p:extLst>
   </p:cSld>
@@ -3652,7 +3652,7 @@
           <p:cNvPr id="2" name="标题 1">
             <a:extLst>
               <a:ext uri="{FF2B5EF4-FFF2-40B4-BE49-F238E27FC236}">
-                <a16:creationId xmlns:a16="http://schemas.microsoft.com/office/drawing/2014/main" id="{B6824F01-3F0F-C9DF-1CCE-4ADA3019A407}"/>
+                <a16:creationId xmlns:a16="http://schemas.microsoft.com/office/drawing/2014/main" id="{42978FA5-F298-052F-0306-DE79CA7E9ABC}"/>
               </a:ext>
             </a:extLst>
           </p:cNvPr>
@@ -3680,7 +3680,7 @@
           <p:cNvPr id="3" name="内容占位符 2">
             <a:extLst>
               <a:ext uri="{FF2B5EF4-FFF2-40B4-BE49-F238E27FC236}">
-                <a16:creationId xmlns:a16="http://schemas.microsoft.com/office/drawing/2014/main" id="{93575218-F7E4-3C92-6B23-250E66E800DC}"/>
+                <a16:creationId xmlns:a16="http://schemas.microsoft.com/office/drawing/2014/main" id="{35E211BE-198E-84B5-9BF8-DEEE705A5C42}"/>
               </a:ext>
             </a:extLst>
           </p:cNvPr>
@@ -3737,7 +3737,7 @@
           <p:cNvPr id="4" name="日期占位符 3">
             <a:extLst>
               <a:ext uri="{FF2B5EF4-FFF2-40B4-BE49-F238E27FC236}">
-                <a16:creationId xmlns:a16="http://schemas.microsoft.com/office/drawing/2014/main" id="{9C747C1E-0588-523C-5F78-F43F5A6A980F}"/>
+                <a16:creationId xmlns:a16="http://schemas.microsoft.com/office/drawing/2014/main" id="{6A60CB10-ACCF-B4EB-A976-BC6640BD1F28}"/>
               </a:ext>
             </a:extLst>
           </p:cNvPr>
@@ -3753,7 +3753,7 @@
           <a:bodyPr/>
           <a:lstStyle/>
           <a:p>
-            <a:fld id="{12CCD2F0-1229-427F-8DED-D4160314B5FF}" type="datetimeFigureOut">
+            <a:fld id="{46AEA13A-38A6-4884-A297-BE05C8B99F63}" type="datetimeFigureOut">
               <a:rPr lang="zh-CN" altLang="en-US" smtClean="0"/>
               <a:t>2026/10/16</a:t>
             </a:fld>
@@ -3766,7 +3766,7 @@
           <p:cNvPr id="5" name="页脚占位符 4">
             <a:extLst>
               <a:ext uri="{FF2B5EF4-FFF2-40B4-BE49-F238E27FC236}">
-                <a16:creationId xmlns:a16="http://schemas.microsoft.com/office/drawing/2014/main" id="{2FF066B8-378D-77F6-0155-5A736DD7E4BE}"/>
+                <a16:creationId xmlns:a16="http://schemas.microsoft.com/office/drawing/2014/main" id="{CBA06666-113C-1169-4865-883ED40D2406}"/>
               </a:ext>
             </a:extLst>
           </p:cNvPr>
@@ -3791,7 +3791,7 @@
           <p:cNvPr id="6" name="灯片编号占位符 5">
             <a:extLst>
               <a:ext uri="{FF2B5EF4-FFF2-40B4-BE49-F238E27FC236}">
-                <a16:creationId xmlns:a16="http://schemas.microsoft.com/office/drawing/2014/main" id="{4876F9B7-2FD1-75C1-0F72-D44D146CDABB}"/>
+                <a16:creationId xmlns:a16="http://schemas.microsoft.com/office/drawing/2014/main" id="{F93F371D-6B10-68F4-8CAC-7DBECAE46371}"/>
               </a:ext>
             </a:extLst>
           </p:cNvPr>
@@ -3807,7 +3807,7 @@
           <a:bodyPr/>
           <a:lstStyle/>
           <a:p>
-            <a:fld id="{84077ECE-D770-4FDA-A17E-E75B8EA1220F}" type="slidenum">
+            <a:fld id="{B165BA6E-6F74-4E19-BCC8-1D3F5CECF083}" type="slidenum">
               <a:rPr lang="zh-CN" altLang="en-US" smtClean="0"/>
               <a:t>‹#›</a:t>
             </a:fld>
@@ -3818,7 +3818,7 @@
     </p:spTree>
     <p:extLst>
       <p:ext uri="{BB962C8B-B14F-4D97-AF65-F5344CB8AC3E}">
-        <p14:creationId xmlns:p14="http://schemas.microsoft.com/office/powerpoint/2010/main" val="753031172"/>
+        <p14:creationId xmlns:p14="http://schemas.microsoft.com/office/powerpoint/2010/main" val="1225538857"/>
       </p:ext>
     </p:extLst>
   </p:cSld>
@@ -3850,7 +3850,7 @@
           <p:cNvPr id="2" name="标题 1">
             <a:extLst>
               <a:ext uri="{FF2B5EF4-FFF2-40B4-BE49-F238E27FC236}">
-                <a16:creationId xmlns:a16="http://schemas.microsoft.com/office/drawing/2014/main" id="{BEAEEC05-7143-CDB0-530B-30CD32C91161}"/>
+                <a16:creationId xmlns:a16="http://schemas.microsoft.com/office/drawing/2014/main" id="{52FAC21A-80F2-6218-13D2-BFD15B254A36}"/>
               </a:ext>
             </a:extLst>
           </p:cNvPr>
@@ -3887,7 +3887,7 @@
           <p:cNvPr id="3" name="文本占位符 2">
             <a:extLst>
               <a:ext uri="{FF2B5EF4-FFF2-40B4-BE49-F238E27FC236}">
-                <a16:creationId xmlns:a16="http://schemas.microsoft.com/office/drawing/2014/main" id="{07ADC3AD-1BE4-EA3C-3467-51EED4F7E996}"/>
+                <a16:creationId xmlns:a16="http://schemas.microsoft.com/office/drawing/2014/main" id="{DC1F0AD4-21E9-1F62-B4D2-920DAE63B10D}"/>
               </a:ext>
             </a:extLst>
           </p:cNvPr>
@@ -4012,7 +4012,7 @@
           <p:cNvPr id="4" name="日期占位符 3">
             <a:extLst>
               <a:ext uri="{FF2B5EF4-FFF2-40B4-BE49-F238E27FC236}">
-                <a16:creationId xmlns:a16="http://schemas.microsoft.com/office/drawing/2014/main" id="{2A22CF15-9719-24E4-6937-69ED2673E0D0}"/>
+                <a16:creationId xmlns:a16="http://schemas.microsoft.com/office/drawing/2014/main" id="{F75D2EA1-1661-1761-9DF9-B469DF07E822}"/>
               </a:ext>
             </a:extLst>
           </p:cNvPr>
@@ -4028,7 +4028,7 @@
           <a:bodyPr/>
           <a:lstStyle/>
           <a:p>
-            <a:fld id="{12CCD2F0-1229-427F-8DED-D4160314B5FF}" type="datetimeFigureOut">
+            <a:fld id="{46AEA13A-38A6-4884-A297-BE05C8B99F63}" type="datetimeFigureOut">
               <a:rPr lang="zh-CN" altLang="en-US" smtClean="0"/>
               <a:t>2026/10/16</a:t>
             </a:fld>
@@ -4041,7 +4041,7 @@
           <p:cNvPr id="5" name="页脚占位符 4">
             <a:extLst>
               <a:ext uri="{FF2B5EF4-FFF2-40B4-BE49-F238E27FC236}">
-                <a16:creationId xmlns:a16="http://schemas.microsoft.com/office/drawing/2014/main" id="{4D53BD40-8F5A-B1C7-2377-2E027888E3E8}"/>
+                <a16:creationId xmlns:a16="http://schemas.microsoft.com/office/drawing/2014/main" id="{FB349949-B550-BEAE-5659-377F53006217}"/>
               </a:ext>
             </a:extLst>
           </p:cNvPr>
@@ -4066,7 +4066,7 @@
           <p:cNvPr id="6" name="灯片编号占位符 5">
             <a:extLst>
               <a:ext uri="{FF2B5EF4-FFF2-40B4-BE49-F238E27FC236}">
-                <a16:creationId xmlns:a16="http://schemas.microsoft.com/office/drawing/2014/main" id="{74677CFF-5602-6D18-FD0A-77FDB1A99AE9}"/>
+                <a16:creationId xmlns:a16="http://schemas.microsoft.com/office/drawing/2014/main" id="{85C0A906-796E-006F-9ACD-918FFD556514}"/>
               </a:ext>
             </a:extLst>
           </p:cNvPr>
@@ -4082,7 +4082,7 @@
           <a:bodyPr/>
           <a:lstStyle/>
           <a:p>
-            <a:fld id="{84077ECE-D770-4FDA-A17E-E75B8EA1220F}" type="slidenum">
+            <a:fld id="{B165BA6E-6F74-4E19-BCC8-1D3F5CECF083}" type="slidenum">
               <a:rPr lang="zh-CN" altLang="en-US" smtClean="0"/>
               <a:t>‹#›</a:t>
             </a:fld>
@@ -4093,7 +4093,7 @@
     </p:spTree>
     <p:extLst>
       <p:ext uri="{BB962C8B-B14F-4D97-AF65-F5344CB8AC3E}">
-        <p14:creationId xmlns:p14="http://schemas.microsoft.com/office/powerpoint/2010/main" val="834510890"/>
+        <p14:creationId xmlns:p14="http://schemas.microsoft.com/office/powerpoint/2010/main" val="1559260307"/>
       </p:ext>
     </p:extLst>
   </p:cSld>
@@ -4125,7 +4125,7 @@
           <p:cNvPr id="2" name="标题 1">
             <a:extLst>
               <a:ext uri="{FF2B5EF4-FFF2-40B4-BE49-F238E27FC236}">
-                <a16:creationId xmlns:a16="http://schemas.microsoft.com/office/drawing/2014/main" id="{C686B99F-8B82-32C7-0504-D98B77970F6B}"/>
+                <a16:creationId xmlns:a16="http://schemas.microsoft.com/office/drawing/2014/main" id="{326774ED-B5C3-B253-765D-010E20DE9277}"/>
               </a:ext>
             </a:extLst>
           </p:cNvPr>
@@ -4153,7 +4153,7 @@
           <p:cNvPr id="3" name="内容占位符 2">
             <a:extLst>
               <a:ext uri="{FF2B5EF4-FFF2-40B4-BE49-F238E27FC236}">
-                <a16:creationId xmlns:a16="http://schemas.microsoft.com/office/drawing/2014/main" id="{3F9C1364-4EDF-1C93-A1DA-03AF227C9C51}"/>
+                <a16:creationId xmlns:a16="http://schemas.microsoft.com/office/drawing/2014/main" id="{754099BB-D2F2-1F3A-36C7-B217C9AC29F1}"/>
               </a:ext>
             </a:extLst>
           </p:cNvPr>
@@ -4215,7 +4215,7 @@
           <p:cNvPr id="4" name="内容占位符 3">
             <a:extLst>
               <a:ext uri="{FF2B5EF4-FFF2-40B4-BE49-F238E27FC236}">
-                <a16:creationId xmlns:a16="http://schemas.microsoft.com/office/drawing/2014/main" id="{F69955E9-EB1A-3007-C86C-B23D7E11EEFC}"/>
+                <a16:creationId xmlns:a16="http://schemas.microsoft.com/office/drawing/2014/main" id="{31CC5FB6-4D63-D087-D76C-CAC8B66E37DF}"/>
               </a:ext>
             </a:extLst>
           </p:cNvPr>
@@ -4277,7 +4277,7 @@
           <p:cNvPr id="5" name="日期占位符 4">
             <a:extLst>
               <a:ext uri="{FF2B5EF4-FFF2-40B4-BE49-F238E27FC236}">
-                <a16:creationId xmlns:a16="http://schemas.microsoft.com/office/drawing/2014/main" id="{0B2D564F-0838-ED8A-3505-BF35B80CEAB8}"/>
+                <a16:creationId xmlns:a16="http://schemas.microsoft.com/office/drawing/2014/main" id="{0EEBEBA2-8439-12FD-66A3-A5BB61274A04}"/>
               </a:ext>
             </a:extLst>
           </p:cNvPr>
@@ -4293,7 +4293,7 @@
           <a:bodyPr/>
           <a:lstStyle/>
           <a:p>
-            <a:fld id="{12CCD2F0-1229-427F-8DED-D4160314B5FF}" type="datetimeFigureOut">
+            <a:fld id="{46AEA13A-38A6-4884-A297-BE05C8B99F63}" type="datetimeFigureOut">
               <a:rPr lang="zh-CN" altLang="en-US" smtClean="0"/>
               <a:t>2026/10/16</a:t>
             </a:fld>
@@ -4306,7 +4306,7 @@
           <p:cNvPr id="6" name="页脚占位符 5">
             <a:extLst>
               <a:ext uri="{FF2B5EF4-FFF2-40B4-BE49-F238E27FC236}">
-                <a16:creationId xmlns:a16="http://schemas.microsoft.com/office/drawing/2014/main" id="{8D0934E8-139B-A851-557F-1A7CB1090169}"/>
+                <a16:creationId xmlns:a16="http://schemas.microsoft.com/office/drawing/2014/main" id="{8364F713-EF0F-32E7-9936-8C5718D3182F}"/>
               </a:ext>
             </a:extLst>
           </p:cNvPr>
@@ -4331,7 +4331,7 @@
           <p:cNvPr id="7" name="灯片编号占位符 6">
             <a:extLst>
               <a:ext uri="{FF2B5EF4-FFF2-40B4-BE49-F238E27FC236}">
-                <a16:creationId xmlns:a16="http://schemas.microsoft.com/office/drawing/2014/main" id="{51F9A869-205D-71DA-4CE0-2AF15D20003F}"/>
+                <a16:creationId xmlns:a16="http://schemas.microsoft.com/office/drawing/2014/main" id="{0DAED093-1017-6012-026E-06FE0E5E7D57}"/>
               </a:ext>
             </a:extLst>
           </p:cNvPr>
@@ -4347,7 +4347,7 @@
           <a:bodyPr/>
           <a:lstStyle/>
           <a:p>
-            <a:fld id="{84077ECE-D770-4FDA-A17E-E75B8EA1220F}" type="slidenum">
+            <a:fld id="{B165BA6E-6F74-4E19-BCC8-1D3F5CECF083}" type="slidenum">
               <a:rPr lang="zh-CN" altLang="en-US" smtClean="0"/>
               <a:t>‹#›</a:t>
             </a:fld>
@@ -4358,7 +4358,7 @@
     </p:spTree>
     <p:extLst>
       <p:ext uri="{BB962C8B-B14F-4D97-AF65-F5344CB8AC3E}">
-        <p14:creationId xmlns:p14="http://schemas.microsoft.com/office/powerpoint/2010/main" val="634314250"/>
+        <p14:creationId xmlns:p14="http://schemas.microsoft.com/office/powerpoint/2010/main" val="1938484231"/>
       </p:ext>
     </p:extLst>
   </p:cSld>
@@ -4390,7 +4390,7 @@
           <p:cNvPr id="2" name="标题 1">
             <a:extLst>
               <a:ext uri="{FF2B5EF4-FFF2-40B4-BE49-F238E27FC236}">
-                <a16:creationId xmlns:a16="http://schemas.microsoft.com/office/drawing/2014/main" id="{62E89B9F-5E97-3569-CFF3-C218E1C147F5}"/>
+                <a16:creationId xmlns:a16="http://schemas.microsoft.com/office/drawing/2014/main" id="{26F101F4-F8F8-AF87-0E04-4FEB4142F871}"/>
               </a:ext>
             </a:extLst>
           </p:cNvPr>
@@ -4423,7 +4423,7 @@
           <p:cNvPr id="3" name="文本占位符 2">
             <a:extLst>
               <a:ext uri="{FF2B5EF4-FFF2-40B4-BE49-F238E27FC236}">
-                <a16:creationId xmlns:a16="http://schemas.microsoft.com/office/drawing/2014/main" id="{C62EB24F-9A1C-54E1-D586-E4F59EE87112}"/>
+                <a16:creationId xmlns:a16="http://schemas.microsoft.com/office/drawing/2014/main" id="{EBD8773B-02BE-9949-A0B0-EF86563FEF66}"/>
               </a:ext>
             </a:extLst>
           </p:cNvPr>
@@ -4494,7 +4494,7 @@
           <p:cNvPr id="4" name="内容占位符 3">
             <a:extLst>
               <a:ext uri="{FF2B5EF4-FFF2-40B4-BE49-F238E27FC236}">
-                <a16:creationId xmlns:a16="http://schemas.microsoft.com/office/drawing/2014/main" id="{AC936F3B-7E3E-77D1-D438-216E833A49F0}"/>
+                <a16:creationId xmlns:a16="http://schemas.microsoft.com/office/drawing/2014/main" id="{444D8E05-2E8B-853B-7F8E-6A02F8DD0F33}"/>
               </a:ext>
             </a:extLst>
           </p:cNvPr>
@@ -4556,7 +4556,7 @@
           <p:cNvPr id="5" name="文本占位符 4">
             <a:extLst>
               <a:ext uri="{FF2B5EF4-FFF2-40B4-BE49-F238E27FC236}">
-                <a16:creationId xmlns:a16="http://schemas.microsoft.com/office/drawing/2014/main" id="{E3031633-E28A-1213-B9C8-BC6091143E3B}"/>
+                <a16:creationId xmlns:a16="http://schemas.microsoft.com/office/drawing/2014/main" id="{D2779CCF-8E5D-A16A-FB4C-7FE43AA9715F}"/>
               </a:ext>
             </a:extLst>
           </p:cNvPr>
@@ -4627,7 +4627,7 @@
           <p:cNvPr id="6" name="内容占位符 5">
             <a:extLst>
               <a:ext uri="{FF2B5EF4-FFF2-40B4-BE49-F238E27FC236}">
-                <a16:creationId xmlns:a16="http://schemas.microsoft.com/office/drawing/2014/main" id="{5AC55A2D-8255-F6EE-323A-BF9F387EAD62}"/>
+                <a16:creationId xmlns:a16="http://schemas.microsoft.com/office/drawing/2014/main" id="{83449D1D-BAC1-5451-E4A5-696F75DB7CFA}"/>
               </a:ext>
             </a:extLst>
           </p:cNvPr>
@@ -4689,7 +4689,7 @@
           <p:cNvPr id="7" name="日期占位符 6">
             <a:extLst>
               <a:ext uri="{FF2B5EF4-FFF2-40B4-BE49-F238E27FC236}">
-                <a16:creationId xmlns:a16="http://schemas.microsoft.com/office/drawing/2014/main" id="{A3E8D341-043E-29AE-236D-793195F15274}"/>
+                <a16:creationId xmlns:a16="http://schemas.microsoft.com/office/drawing/2014/main" id="{AC17F950-236C-F4B8-2BDD-E0AC505520D9}"/>
               </a:ext>
             </a:extLst>
           </p:cNvPr>
@@ -4705,7 +4705,7 @@
           <a:bodyPr/>
           <a:lstStyle/>
           <a:p>
-            <a:fld id="{12CCD2F0-1229-427F-8DED-D4160314B5FF}" type="datetimeFigureOut">
+            <a:fld id="{46AEA13A-38A6-4884-A297-BE05C8B99F63}" type="datetimeFigureOut">
               <a:rPr lang="zh-CN" altLang="en-US" smtClean="0"/>
               <a:t>2026/10/16</a:t>
             </a:fld>
@@ -4718,7 +4718,7 @@
           <p:cNvPr id="8" name="页脚占位符 7">
             <a:extLst>
               <a:ext uri="{FF2B5EF4-FFF2-40B4-BE49-F238E27FC236}">
-                <a16:creationId xmlns:a16="http://schemas.microsoft.com/office/drawing/2014/main" id="{E4BCF08D-56C7-CAC4-4D3A-588214E2F0B4}"/>
+                <a16:creationId xmlns:a16="http://schemas.microsoft.com/office/drawing/2014/main" id="{FDEB4F95-C78C-0D1B-11E0-B7D1CFC8C3C3}"/>
               </a:ext>
             </a:extLst>
           </p:cNvPr>
@@ -4743,7 +4743,7 @@
           <p:cNvPr id="9" name="灯片编号占位符 8">
             <a:extLst>
               <a:ext uri="{FF2B5EF4-FFF2-40B4-BE49-F238E27FC236}">
-                <a16:creationId xmlns:a16="http://schemas.microsoft.com/office/drawing/2014/main" id="{8FA32B65-43EA-0FB4-A69B-9C816C463D69}"/>
+                <a16:creationId xmlns:a16="http://schemas.microsoft.com/office/drawing/2014/main" id="{413EB935-FE1C-AB0E-B260-7A9BB9D27B34}"/>
               </a:ext>
             </a:extLst>
           </p:cNvPr>
@@ -4759,7 +4759,7 @@
           <a:bodyPr/>
           <a:lstStyle/>
           <a:p>
-            <a:fld id="{84077ECE-D770-4FDA-A17E-E75B8EA1220F}" type="slidenum">
+            <a:fld id="{B165BA6E-6F74-4E19-BCC8-1D3F5CECF083}" type="slidenum">
               <a:rPr lang="zh-CN" altLang="en-US" smtClean="0"/>
               <a:t>‹#›</a:t>
             </a:fld>
@@ -4770,7 +4770,7 @@
     </p:spTree>
     <p:extLst>
       <p:ext uri="{BB962C8B-B14F-4D97-AF65-F5344CB8AC3E}">
-        <p14:creationId xmlns:p14="http://schemas.microsoft.com/office/powerpoint/2010/main" val="1176181883"/>
+        <p14:creationId xmlns:p14="http://schemas.microsoft.com/office/powerpoint/2010/main" val="756179518"/>
       </p:ext>
     </p:extLst>
   </p:cSld>
@@ -4802,7 +4802,7 @@
           <p:cNvPr id="2" name="标题 1">
             <a:extLst>
               <a:ext uri="{FF2B5EF4-FFF2-40B4-BE49-F238E27FC236}">
-                <a16:creationId xmlns:a16="http://schemas.microsoft.com/office/drawing/2014/main" id="{515F3A67-426B-6CAB-71EB-ABDCF745F6BC}"/>
+                <a16:creationId xmlns:a16="http://schemas.microsoft.com/office/drawing/2014/main" id="{0A291292-B3A7-9DEB-6225-310F33187E8D}"/>
               </a:ext>
             </a:extLst>
           </p:cNvPr>
@@ -4830,7 +4830,7 @@
           <p:cNvPr id="3" name="日期占位符 2">
             <a:extLst>
               <a:ext uri="{FF2B5EF4-FFF2-40B4-BE49-F238E27FC236}">
-                <a16:creationId xmlns:a16="http://schemas.microsoft.com/office/drawing/2014/main" id="{170D66AF-6D67-0E64-F8F4-E278B2D2F30D}"/>
+                <a16:creationId xmlns:a16="http://schemas.microsoft.com/office/drawing/2014/main" id="{05CCF622-1456-B7C0-5793-48814EAD53E0}"/>
               </a:ext>
             </a:extLst>
           </p:cNvPr>
@@ -4846,7 +4846,7 @@
           <a:bodyPr/>
           <a:lstStyle/>
           <a:p>
-            <a:fld id="{12CCD2F0-1229-427F-8DED-D4160314B5FF}" type="datetimeFigureOut">
+            <a:fld id="{46AEA13A-38A6-4884-A297-BE05C8B99F63}" type="datetimeFigureOut">
               <a:rPr lang="zh-CN" altLang="en-US" smtClean="0"/>
               <a:t>2026/10/16</a:t>
             </a:fld>
@@ -4859,7 +4859,7 @@
           <p:cNvPr id="4" name="页脚占位符 3">
             <a:extLst>
               <a:ext uri="{FF2B5EF4-FFF2-40B4-BE49-F238E27FC236}">
-                <a16:creationId xmlns:a16="http://schemas.microsoft.com/office/drawing/2014/main" id="{C83449AA-F322-CEE6-70E8-A2309A4D2165}"/>
+                <a16:creationId xmlns:a16="http://schemas.microsoft.com/office/drawing/2014/main" id="{A252C261-028E-B9A5-1DC8-3104D0C4DA1E}"/>
               </a:ext>
             </a:extLst>
           </p:cNvPr>
@@ -4884,7 +4884,7 @@
           <p:cNvPr id="5" name="灯片编号占位符 4">
             <a:extLst>
               <a:ext uri="{FF2B5EF4-FFF2-40B4-BE49-F238E27FC236}">
-                <a16:creationId xmlns:a16="http://schemas.microsoft.com/office/drawing/2014/main" id="{33F80D2E-B4BD-F70E-14B0-1D2BC5016552}"/>
+                <a16:creationId xmlns:a16="http://schemas.microsoft.com/office/drawing/2014/main" id="{D4FE5E69-8456-7584-CB67-E0FA0191B23B}"/>
               </a:ext>
             </a:extLst>
           </p:cNvPr>
@@ -4900,7 +4900,7 @@
           <a:bodyPr/>
           <a:lstStyle/>
           <a:p>
-            <a:fld id="{84077ECE-D770-4FDA-A17E-E75B8EA1220F}" type="slidenum">
+            <a:fld id="{B165BA6E-6F74-4E19-BCC8-1D3F5CECF083}" type="slidenum">
               <a:rPr lang="zh-CN" altLang="en-US" smtClean="0"/>
               <a:t>‹#›</a:t>
             </a:fld>
@@ -4911,7 +4911,7 @@
     </p:spTree>
     <p:extLst>
       <p:ext uri="{BB962C8B-B14F-4D97-AF65-F5344CB8AC3E}">
-        <p14:creationId xmlns:p14="http://schemas.microsoft.com/office/powerpoint/2010/main" val="148336781"/>
+        <p14:creationId xmlns:p14="http://schemas.microsoft.com/office/powerpoint/2010/main" val="31540606"/>
       </p:ext>
     </p:extLst>
   </p:cSld>
@@ -4943,7 +4943,7 @@
           <p:cNvPr id="2" name="日期占位符 1">
             <a:extLst>
               <a:ext uri="{FF2B5EF4-FFF2-40B4-BE49-F238E27FC236}">
-                <a16:creationId xmlns:a16="http://schemas.microsoft.com/office/drawing/2014/main" id="{3D042D39-9F4F-064E-5A35-84117399E74D}"/>
+                <a16:creationId xmlns:a16="http://schemas.microsoft.com/office/drawing/2014/main" id="{9FF0A8F2-807B-904F-39C7-6C0A1FAC3795}"/>
               </a:ext>
             </a:extLst>
           </p:cNvPr>
@@ -4959,7 +4959,7 @@
           <a:bodyPr/>
           <a:lstStyle/>
           <a:p>
-            <a:fld id="{12CCD2F0-1229-427F-8DED-D4160314B5FF}" type="datetimeFigureOut">
+            <a:fld id="{46AEA13A-38A6-4884-A297-BE05C8B99F63}" type="datetimeFigureOut">
               <a:rPr lang="zh-CN" altLang="en-US" smtClean="0"/>
               <a:t>2026/10/16</a:t>
             </a:fld>
@@ -4972,7 +4972,7 @@
           <p:cNvPr id="3" name="页脚占位符 2">
             <a:extLst>
               <a:ext uri="{FF2B5EF4-FFF2-40B4-BE49-F238E27FC236}">
-                <a16:creationId xmlns:a16="http://schemas.microsoft.com/office/drawing/2014/main" id="{260E4946-DDC1-3D8B-A9C9-2913BBCA2FBF}"/>
+                <a16:creationId xmlns:a16="http://schemas.microsoft.com/office/drawing/2014/main" id="{E1F4738C-F150-714D-7A42-1530C3E0DB70}"/>
               </a:ext>
             </a:extLst>
           </p:cNvPr>
@@ -4997,7 +4997,7 @@
           <p:cNvPr id="4" name="灯片编号占位符 3">
             <a:extLst>
               <a:ext uri="{FF2B5EF4-FFF2-40B4-BE49-F238E27FC236}">
-                <a16:creationId xmlns:a16="http://schemas.microsoft.com/office/drawing/2014/main" id="{2839969B-D59D-5A31-3858-0CE17E46A277}"/>
+                <a16:creationId xmlns:a16="http://schemas.microsoft.com/office/drawing/2014/main" id="{104CCAB5-5F74-BEFB-A1EC-1F48A4F90817}"/>
               </a:ext>
             </a:extLst>
           </p:cNvPr>
@@ -5013,7 +5013,7 @@
           <a:bodyPr/>
           <a:lstStyle/>
           <a:p>
-            <a:fld id="{84077ECE-D770-4FDA-A17E-E75B8EA1220F}" type="slidenum">
+            <a:fld id="{B165BA6E-6F74-4E19-BCC8-1D3F5CECF083}" type="slidenum">
               <a:rPr lang="zh-CN" altLang="en-US" smtClean="0"/>
               <a:t>‹#›</a:t>
             </a:fld>
@@ -5024,7 +5024,7 @@
     </p:spTree>
     <p:extLst>
       <p:ext uri="{BB962C8B-B14F-4D97-AF65-F5344CB8AC3E}">
-        <p14:creationId xmlns:p14="http://schemas.microsoft.com/office/powerpoint/2010/main" val="2066470966"/>
+        <p14:creationId xmlns:p14="http://schemas.microsoft.com/office/powerpoint/2010/main" val="1441439983"/>
       </p:ext>
     </p:extLst>
   </p:cSld>
@@ -5056,7 +5056,7 @@
           <p:cNvPr id="2" name="标题 1">
             <a:extLst>
               <a:ext uri="{FF2B5EF4-FFF2-40B4-BE49-F238E27FC236}">
-                <a16:creationId xmlns:a16="http://schemas.microsoft.com/office/drawing/2014/main" id="{E961E11D-2EFA-80B2-A188-D93BC3FFF5E5}"/>
+                <a16:creationId xmlns:a16="http://schemas.microsoft.com/office/drawing/2014/main" id="{8D093FAB-AB2E-8764-FF43-3CE15EDBA43F}"/>
               </a:ext>
             </a:extLst>
           </p:cNvPr>
@@ -5093,7 +5093,7 @@
           <p:cNvPr id="3" name="内容占位符 2">
             <a:extLst>
               <a:ext uri="{FF2B5EF4-FFF2-40B4-BE49-F238E27FC236}">
-                <a16:creationId xmlns:a16="http://schemas.microsoft.com/office/drawing/2014/main" id="{44436965-A852-372A-EA20-862493219FE5}"/>
+                <a16:creationId xmlns:a16="http://schemas.microsoft.com/office/drawing/2014/main" id="{90ED7142-FE66-77CC-76B5-A367593A0BB4}"/>
               </a:ext>
             </a:extLst>
           </p:cNvPr>
@@ -5183,7 +5183,7 @@
           <p:cNvPr id="4" name="文本占位符 3">
             <a:extLst>
               <a:ext uri="{FF2B5EF4-FFF2-40B4-BE49-F238E27FC236}">
-                <a16:creationId xmlns:a16="http://schemas.microsoft.com/office/drawing/2014/main" id="{1BCE86AE-F8B6-2B02-CA02-260784CBC784}"/>
+                <a16:creationId xmlns:a16="http://schemas.microsoft.com/office/drawing/2014/main" id="{450D5B90-C9F4-A444-DAFA-3FF0E8C92A76}"/>
               </a:ext>
             </a:extLst>
           </p:cNvPr>
@@ -5254,7 +5254,7 @@
           <p:cNvPr id="5" name="日期占位符 4">
             <a:extLst>
               <a:ext uri="{FF2B5EF4-FFF2-40B4-BE49-F238E27FC236}">
-                <a16:creationId xmlns:a16="http://schemas.microsoft.com/office/drawing/2014/main" id="{37C7873D-FE0C-9CB2-242D-67510F715E08}"/>
+                <a16:creationId xmlns:a16="http://schemas.microsoft.com/office/drawing/2014/main" id="{8493C6E7-A965-08DA-9F27-3CEA636E45FC}"/>
               </a:ext>
             </a:extLst>
           </p:cNvPr>
@@ -5270,7 +5270,7 @@
           <a:bodyPr/>
           <a:lstStyle/>
           <a:p>
-            <a:fld id="{12CCD2F0-1229-427F-8DED-D4160314B5FF}" type="datetimeFigureOut">
+            <a:fld id="{46AEA13A-38A6-4884-A297-BE05C8B99F63}" type="datetimeFigureOut">
               <a:rPr lang="zh-CN" altLang="en-US" smtClean="0"/>
               <a:t>2026/10/16</a:t>
             </a:fld>
@@ -5283,7 +5283,7 @@
           <p:cNvPr id="6" name="页脚占位符 5">
             <a:extLst>
               <a:ext uri="{FF2B5EF4-FFF2-40B4-BE49-F238E27FC236}">
-                <a16:creationId xmlns:a16="http://schemas.microsoft.com/office/drawing/2014/main" id="{BD9B70D3-C736-5526-2841-C368A8142D67}"/>
+                <a16:creationId xmlns:a16="http://schemas.microsoft.com/office/drawing/2014/main" id="{50C1894A-3E59-D5A6-5FDB-B9C78FB1E689}"/>
               </a:ext>
             </a:extLst>
           </p:cNvPr>
@@ -5308,7 +5308,7 @@
           <p:cNvPr id="7" name="灯片编号占位符 6">
             <a:extLst>
               <a:ext uri="{FF2B5EF4-FFF2-40B4-BE49-F238E27FC236}">
-                <a16:creationId xmlns:a16="http://schemas.microsoft.com/office/drawing/2014/main" id="{CD36384C-0E4F-3FEF-40F1-02AB67B85FE1}"/>
+                <a16:creationId xmlns:a16="http://schemas.microsoft.com/office/drawing/2014/main" id="{9E881075-EA79-ABB1-CE41-EC996851D652}"/>
               </a:ext>
             </a:extLst>
           </p:cNvPr>
@@ -5324,7 +5324,7 @@
           <a:bodyPr/>
           <a:lstStyle/>
           <a:p>
-            <a:fld id="{84077ECE-D770-4FDA-A17E-E75B8EA1220F}" type="slidenum">
+            <a:fld id="{B165BA6E-6F74-4E19-BCC8-1D3F5CECF083}" type="slidenum">
               <a:rPr lang="zh-CN" altLang="en-US" smtClean="0"/>
               <a:t>‹#›</a:t>
             </a:fld>
@@ -5335,7 +5335,7 @@
     </p:spTree>
     <p:extLst>
       <p:ext uri="{BB962C8B-B14F-4D97-AF65-F5344CB8AC3E}">
-        <p14:creationId xmlns:p14="http://schemas.microsoft.com/office/powerpoint/2010/main" val="2845701172"/>
+        <p14:creationId xmlns:p14="http://schemas.microsoft.com/office/powerpoint/2010/main" val="2339729494"/>
       </p:ext>
     </p:extLst>
   </p:cSld>
@@ -5367,7 +5367,7 @@
           <p:cNvPr id="2" name="标题 1">
             <a:extLst>
               <a:ext uri="{FF2B5EF4-FFF2-40B4-BE49-F238E27FC236}">
-                <a16:creationId xmlns:a16="http://schemas.microsoft.com/office/drawing/2014/main" id="{443EE702-4B09-036A-73B4-285B2F22FD50}"/>
+                <a16:creationId xmlns:a16="http://schemas.microsoft.com/office/drawing/2014/main" id="{2956DD85-D34C-C832-699A-6F1B9687C543}"/>
               </a:ext>
             </a:extLst>
           </p:cNvPr>
@@ -5404,7 +5404,7 @@
           <p:cNvPr id="3" name="图片占位符 2">
             <a:extLst>
               <a:ext uri="{FF2B5EF4-FFF2-40B4-BE49-F238E27FC236}">
-                <a16:creationId xmlns:a16="http://schemas.microsoft.com/office/drawing/2014/main" id="{0EE2013B-3A8E-416B-D94F-7504A5FE1349}"/>
+                <a16:creationId xmlns:a16="http://schemas.microsoft.com/office/drawing/2014/main" id="{7B34068F-615F-09DC-BD73-5C04F179168F}"/>
               </a:ext>
             </a:extLst>
           </p:cNvPr>
@@ -5471,7 +5471,7 @@
           <p:cNvPr id="4" name="文本占位符 3">
             <a:extLst>
               <a:ext uri="{FF2B5EF4-FFF2-40B4-BE49-F238E27FC236}">
-                <a16:creationId xmlns:a16="http://schemas.microsoft.com/office/drawing/2014/main" id="{4D280956-57D2-0D5C-D127-F0F62FA9A37F}"/>
+                <a16:creationId xmlns:a16="http://schemas.microsoft.com/office/drawing/2014/main" id="{29D09B7A-9891-9EC7-8C01-80BF739049AC}"/>
               </a:ext>
             </a:extLst>
           </p:cNvPr>
@@ -5542,7 +5542,7 @@
           <p:cNvPr id="5" name="日期占位符 4">
             <a:extLst>
               <a:ext uri="{FF2B5EF4-FFF2-40B4-BE49-F238E27FC236}">
-                <a16:creationId xmlns:a16="http://schemas.microsoft.com/office/drawing/2014/main" id="{2A159B36-437C-8E08-A083-97A5F0C9FBC2}"/>
+                <a16:creationId xmlns:a16="http://schemas.microsoft.com/office/drawing/2014/main" id="{A63DCCA9-9BA7-917B-7AD8-66245F915C21}"/>
               </a:ext>
             </a:extLst>
           </p:cNvPr>
@@ -5558,7 +5558,7 @@
           <a:bodyPr/>
           <a:lstStyle/>
           <a:p>
-            <a:fld id="{12CCD2F0-1229-427F-8DED-D4160314B5FF}" type="datetimeFigureOut">
+            <a:fld id="{46AEA13A-38A6-4884-A297-BE05C8B99F63}" type="datetimeFigureOut">
               <a:rPr lang="zh-CN" altLang="en-US" smtClean="0"/>
               <a:t>2026/10/16</a:t>
             </a:fld>
@@ -5571,7 +5571,7 @@
           <p:cNvPr id="6" name="页脚占位符 5">
             <a:extLst>
               <a:ext uri="{FF2B5EF4-FFF2-40B4-BE49-F238E27FC236}">
-                <a16:creationId xmlns:a16="http://schemas.microsoft.com/office/drawing/2014/main" id="{DCEAE3E9-87D9-0FA5-8F36-C07CA0B8572B}"/>
+                <a16:creationId xmlns:a16="http://schemas.microsoft.com/office/drawing/2014/main" id="{567D9C4A-21A7-9D20-B570-87271E7A064B}"/>
               </a:ext>
             </a:extLst>
           </p:cNvPr>
@@ -5596,7 +5596,7 @@
           <p:cNvPr id="7" name="灯片编号占位符 6">
             <a:extLst>
               <a:ext uri="{FF2B5EF4-FFF2-40B4-BE49-F238E27FC236}">
-                <a16:creationId xmlns:a16="http://schemas.microsoft.com/office/drawing/2014/main" id="{93D1CA11-ED26-48EA-0D8A-3EAC41D41D94}"/>
+                <a16:creationId xmlns:a16="http://schemas.microsoft.com/office/drawing/2014/main" id="{B880C641-F715-78AE-FCAB-1F811B20EA73}"/>
               </a:ext>
             </a:extLst>
           </p:cNvPr>
@@ -5612,7 +5612,7 @@
           <a:bodyPr/>
           <a:lstStyle/>
           <a:p>
-            <a:fld id="{84077ECE-D770-4FDA-A17E-E75B8EA1220F}" type="slidenum">
+            <a:fld id="{B165BA6E-6F74-4E19-BCC8-1D3F5CECF083}" type="slidenum">
               <a:rPr lang="zh-CN" altLang="en-US" smtClean="0"/>
               <a:t>‹#›</a:t>
             </a:fld>
@@ -5623,7 +5623,7 @@
     </p:spTree>
     <p:extLst>
       <p:ext uri="{BB962C8B-B14F-4D97-AF65-F5344CB8AC3E}">
-        <p14:creationId xmlns:p14="http://schemas.microsoft.com/office/powerpoint/2010/main" val="3275976157"/>
+        <p14:creationId xmlns:p14="http://schemas.microsoft.com/office/powerpoint/2010/main" val="3274584093"/>
       </p:ext>
     </p:extLst>
   </p:cSld>
@@ -5660,7 +5660,7 @@
           <p:cNvPr id="2" name="标题占位符 1">
             <a:extLst>
               <a:ext uri="{FF2B5EF4-FFF2-40B4-BE49-F238E27FC236}">
-                <a16:creationId xmlns:a16="http://schemas.microsoft.com/office/drawing/2014/main" id="{02010AE4-B662-37FD-82A5-5DADDC1A9B65}"/>
+                <a16:creationId xmlns:a16="http://schemas.microsoft.com/office/drawing/2014/main" id="{61CCD6FC-8C1A-9D7E-B62C-AF1CF419DF64}"/>
               </a:ext>
             </a:extLst>
           </p:cNvPr>
@@ -5698,7 +5698,7 @@
           <p:cNvPr id="3" name="文本占位符 2">
             <a:extLst>
               <a:ext uri="{FF2B5EF4-FFF2-40B4-BE49-F238E27FC236}">
-                <a16:creationId xmlns:a16="http://schemas.microsoft.com/office/drawing/2014/main" id="{4450D86A-FDDC-1B32-D35B-AB4FCE9DFA76}"/>
+                <a16:creationId xmlns:a16="http://schemas.microsoft.com/office/drawing/2014/main" id="{67AEEDEE-0124-F926-2E8D-DBFFAAE09CC6}"/>
               </a:ext>
             </a:extLst>
           </p:cNvPr>
@@ -5765,7 +5765,7 @@
           <p:cNvPr id="4" name="日期占位符 3">
             <a:extLst>
               <a:ext uri="{FF2B5EF4-FFF2-40B4-BE49-F238E27FC236}">
-                <a16:creationId xmlns:a16="http://schemas.microsoft.com/office/drawing/2014/main" id="{BFEDA65F-05D1-FCE9-80FB-3C33ECFAB562}"/>
+                <a16:creationId xmlns:a16="http://schemas.microsoft.com/office/drawing/2014/main" id="{529D3F38-0A1C-42DD-C1EA-77F765A83EC3}"/>
               </a:ext>
             </a:extLst>
           </p:cNvPr>
@@ -5799,7 +5799,7 @@
             </a:lvl1pPr>
           </a:lstStyle>
           <a:p>
-            <a:fld id="{12CCD2F0-1229-427F-8DED-D4160314B5FF}" type="datetimeFigureOut">
+            <a:fld id="{46AEA13A-38A6-4884-A297-BE05C8B99F63}" type="datetimeFigureOut">
               <a:rPr lang="zh-CN" altLang="en-US" smtClean="0"/>
               <a:t>2026/10/16</a:t>
             </a:fld>
@@ -5812,7 +5812,7 @@
           <p:cNvPr id="5" name="页脚占位符 4">
             <a:extLst>
               <a:ext uri="{FF2B5EF4-FFF2-40B4-BE49-F238E27FC236}">
-                <a16:creationId xmlns:a16="http://schemas.microsoft.com/office/drawing/2014/main" id="{6B5B7145-9A71-2525-72FF-5BF8453667D3}"/>
+                <a16:creationId xmlns:a16="http://schemas.microsoft.com/office/drawing/2014/main" id="{C3CC7DD1-AFF0-A9B1-00F9-F6182906E310}"/>
               </a:ext>
             </a:extLst>
           </p:cNvPr>
@@ -5855,7 +5855,7 @@
           <p:cNvPr id="6" name="灯片编号占位符 5">
             <a:extLst>
               <a:ext uri="{FF2B5EF4-FFF2-40B4-BE49-F238E27FC236}">
-                <a16:creationId xmlns:a16="http://schemas.microsoft.com/office/drawing/2014/main" id="{D229C91C-BF6B-734D-B75F-DBE41AD62D57}"/>
+                <a16:creationId xmlns:a16="http://schemas.microsoft.com/office/drawing/2014/main" id="{DE269033-B9E8-B1B1-7AD9-94C73906C4CD}"/>
               </a:ext>
             </a:extLst>
           </p:cNvPr>
@@ -5889,7 +5889,7 @@
             </a:lvl1pPr>
           </a:lstStyle>
           <a:p>
-            <a:fld id="{84077ECE-D770-4FDA-A17E-E75B8EA1220F}" type="slidenum">
+            <a:fld id="{B165BA6E-6F74-4E19-BCC8-1D3F5CECF083}" type="slidenum">
               <a:rPr lang="zh-CN" altLang="en-US" smtClean="0"/>
               <a:t>‹#›</a:t>
             </a:fld>
@@ -5900,7 +5900,7 @@
     </p:spTree>
     <p:extLst>
       <p:ext uri="{BB962C8B-B14F-4D97-AF65-F5344CB8AC3E}">
-        <p14:creationId xmlns:p14="http://schemas.microsoft.com/office/powerpoint/2010/main" val="2365248594"/>
+        <p14:creationId xmlns:p14="http://schemas.microsoft.com/office/powerpoint/2010/main" val="841742622"/>
       </p:ext>
     </p:extLst>
   </p:cSld>
@@ -6231,7 +6231,7 @@
           <p:cNvPr id="2" name="矩形 1">
             <a:extLst>
               <a:ext uri="{FF2B5EF4-FFF2-40B4-BE49-F238E27FC236}">
-                <a16:creationId xmlns:a16="http://schemas.microsoft.com/office/drawing/2014/main" id="{B45A7706-7875-5A98-38D8-DF3296E981B3}"/>
+                <a16:creationId xmlns:a16="http://schemas.microsoft.com/office/drawing/2014/main" id="{69BD57BC-F791-0EFC-94FB-FE86B8641062}"/>
               </a:ext>
             </a:extLst>
           </p:cNvPr>
@@ -6299,7 +6299,7 @@
           <p:cNvPr id="3" name="文本框 2">
             <a:extLst>
               <a:ext uri="{FF2B5EF4-FFF2-40B4-BE49-F238E27FC236}">
-                <a16:creationId xmlns:a16="http://schemas.microsoft.com/office/drawing/2014/main" id="{5284C347-6CAF-24DF-4F7D-510D0D119114}"/>
+                <a16:creationId xmlns:a16="http://schemas.microsoft.com/office/drawing/2014/main" id="{62A6F1A6-4EEF-7612-BE63-5A0BA9246F78}"/>
               </a:ext>
             </a:extLst>
           </p:cNvPr>
@@ -6347,7 +6347,7 @@
           <p:cNvPr id="4" name="文本框 3">
             <a:extLst>
               <a:ext uri="{FF2B5EF4-FFF2-40B4-BE49-F238E27FC236}">
-                <a16:creationId xmlns:a16="http://schemas.microsoft.com/office/drawing/2014/main" id="{19997033-5EAF-3126-E061-156E25C666FC}"/>
+                <a16:creationId xmlns:a16="http://schemas.microsoft.com/office/drawing/2014/main" id="{EF8E504E-6E6C-E402-CCE0-1ECDC6F10F54}"/>
               </a:ext>
             </a:extLst>
           </p:cNvPr>
@@ -6399,7 +6399,7 @@
           <p:cNvPr id="5" name="文本框 4">
             <a:extLst>
               <a:ext uri="{FF2B5EF4-FFF2-40B4-BE49-F238E27FC236}">
-                <a16:creationId xmlns:a16="http://schemas.microsoft.com/office/drawing/2014/main" id="{65DBDCCF-BD00-B629-01DB-28714A3426D7}"/>
+                <a16:creationId xmlns:a16="http://schemas.microsoft.com/office/drawing/2014/main" id="{BED4FA02-1625-FAFE-9896-E3267E8DBACC}"/>
               </a:ext>
             </a:extLst>
           </p:cNvPr>
@@ -6440,7 +6440,7 @@
           <p:cNvPr id="6" name="文本框 5">
             <a:extLst>
               <a:ext uri="{FF2B5EF4-FFF2-40B4-BE49-F238E27FC236}">
-                <a16:creationId xmlns:a16="http://schemas.microsoft.com/office/drawing/2014/main" id="{251950DA-B1A1-DAB3-D542-B9BBE58E5E1F}"/>
+                <a16:creationId xmlns:a16="http://schemas.microsoft.com/office/drawing/2014/main" id="{03EB96CC-B0DB-D1B4-0891-F3C6E070E6E9}"/>
               </a:ext>
             </a:extLst>
           </p:cNvPr>
@@ -6541,7 +6541,7 @@
           <p:cNvPr id="7" name="文本框 6">
             <a:extLst>
               <a:ext uri="{FF2B5EF4-FFF2-40B4-BE49-F238E27FC236}">
-                <a16:creationId xmlns:a16="http://schemas.microsoft.com/office/drawing/2014/main" id="{897D5CF7-B6DA-E55E-4816-7C5CAAA52F2C}"/>
+                <a16:creationId xmlns:a16="http://schemas.microsoft.com/office/drawing/2014/main" id="{3028463A-B1CA-3BAE-7FC7-489850382E99}"/>
               </a:ext>
             </a:extLst>
           </p:cNvPr>
@@ -6590,7 +6590,7 @@
           <p:cNvPr id="8" name="文本框 7">
             <a:extLst>
               <a:ext uri="{FF2B5EF4-FFF2-40B4-BE49-F238E27FC236}">
-                <a16:creationId xmlns:a16="http://schemas.microsoft.com/office/drawing/2014/main" id="{9226F02A-7BA2-60A2-345A-1BBC6FE243BA}"/>
+                <a16:creationId xmlns:a16="http://schemas.microsoft.com/office/drawing/2014/main" id="{FE917957-88F7-97B3-4221-DCFC0E9ABBF4}"/>
               </a:ext>
             </a:extLst>
           </p:cNvPr>
@@ -6648,7 +6648,7 @@
           <p:cNvPr id="9" name="文本框 8">
             <a:extLst>
               <a:ext uri="{FF2B5EF4-FFF2-40B4-BE49-F238E27FC236}">
-                <a16:creationId xmlns:a16="http://schemas.microsoft.com/office/drawing/2014/main" id="{D51ECB13-C8AA-C91C-F3BF-9AE917ED9C33}"/>
+                <a16:creationId xmlns:a16="http://schemas.microsoft.com/office/drawing/2014/main" id="{ABC78378-6579-D09E-7383-703321781C87}"/>
               </a:ext>
             </a:extLst>
           </p:cNvPr>
@@ -6706,7 +6706,7 @@
           <p:cNvPr id="10" name="文本框 9">
             <a:extLst>
               <a:ext uri="{FF2B5EF4-FFF2-40B4-BE49-F238E27FC236}">
-                <a16:creationId xmlns:a16="http://schemas.microsoft.com/office/drawing/2014/main" id="{590E5629-67D6-6A1C-4722-69DABE65DFBD}"/>
+                <a16:creationId xmlns:a16="http://schemas.microsoft.com/office/drawing/2014/main" id="{922B4BCD-5F20-4D1D-30F4-075DECF23BB3}"/>
               </a:ext>
             </a:extLst>
           </p:cNvPr>
@@ -6774,7 +6774,7 @@
           <p:cNvPr id="12" name="图片 11">
             <a:extLst>
               <a:ext uri="{FF2B5EF4-FFF2-40B4-BE49-F238E27FC236}">
-                <a16:creationId xmlns:a16="http://schemas.microsoft.com/office/drawing/2014/main" id="{0A808D81-F9A4-59A3-9A3D-DEB9B9AEEC0E}"/>
+                <a16:creationId xmlns:a16="http://schemas.microsoft.com/office/drawing/2014/main" id="{2BEB0440-DFF3-DC9C-76C8-3A6478579A14}"/>
               </a:ext>
             </a:extLst>
           </p:cNvPr>
@@ -6810,7 +6810,7 @@
           <p:cNvPr id="14" name="图片 13">
             <a:extLst>
               <a:ext uri="{FF2B5EF4-FFF2-40B4-BE49-F238E27FC236}">
-                <a16:creationId xmlns:a16="http://schemas.microsoft.com/office/drawing/2014/main" id="{D74A89ED-BE72-2C90-5A3E-BBDB4601256D}"/>
+                <a16:creationId xmlns:a16="http://schemas.microsoft.com/office/drawing/2014/main" id="{DF49CB85-0159-76F2-9D4A-8F804D48BE23}"/>
               </a:ext>
             </a:extLst>
           </p:cNvPr>
@@ -6846,7 +6846,7 @@
           <p:cNvPr id="16" name="图片 15">
             <a:extLst>
               <a:ext uri="{FF2B5EF4-FFF2-40B4-BE49-F238E27FC236}">
-                <a16:creationId xmlns:a16="http://schemas.microsoft.com/office/drawing/2014/main" id="{631153C7-2996-71F9-94F0-93AE0E2D1F6E}"/>
+                <a16:creationId xmlns:a16="http://schemas.microsoft.com/office/drawing/2014/main" id="{A1D224BB-E08C-04CD-28C2-20EE53178CD2}"/>
               </a:ext>
             </a:extLst>
           </p:cNvPr>
@@ -6882,7 +6882,7 @@
           <p:cNvPr id="17" name="文本框 16">
             <a:extLst>
               <a:ext uri="{FF2B5EF4-FFF2-40B4-BE49-F238E27FC236}">
-                <a16:creationId xmlns:a16="http://schemas.microsoft.com/office/drawing/2014/main" id="{6280663B-87D7-6670-CD0C-6CC0B7C118B0}"/>
+                <a16:creationId xmlns:a16="http://schemas.microsoft.com/office/drawing/2014/main" id="{94B331A3-6930-5C31-E808-F3946716D698}"/>
               </a:ext>
             </a:extLst>
           </p:cNvPr>
@@ -6931,7 +6931,7 @@
           <p:cNvPr id="18" name="直接连接符 17">
             <a:extLst>
               <a:ext uri="{FF2B5EF4-FFF2-40B4-BE49-F238E27FC236}">
-                <a16:creationId xmlns:a16="http://schemas.microsoft.com/office/drawing/2014/main" id="{2D6A127E-1BAE-5F0A-E296-36C6D5603AD7}"/>
+                <a16:creationId xmlns:a16="http://schemas.microsoft.com/office/drawing/2014/main" id="{265F75CD-51F9-AE85-A360-F6D5AAF70843}"/>
               </a:ext>
             </a:extLst>
           </p:cNvPr>
@@ -6973,7 +6973,7 @@
           <p:cNvPr id="19" name="文本框 18">
             <a:extLst>
               <a:ext uri="{FF2B5EF4-FFF2-40B4-BE49-F238E27FC236}">
-                <a16:creationId xmlns:a16="http://schemas.microsoft.com/office/drawing/2014/main" id="{46A75921-6BD1-3E35-BB6B-1EC229757392}"/>
+                <a16:creationId xmlns:a16="http://schemas.microsoft.com/office/drawing/2014/main" id="{438E321D-3DCE-88B2-C7E3-917AD383B7BF}"/>
               </a:ext>
             </a:extLst>
           </p:cNvPr>
@@ -7054,7 +7054,7 @@
           <p:cNvPr id="20" name="文本框 19">
             <a:extLst>
               <a:ext uri="{FF2B5EF4-FFF2-40B4-BE49-F238E27FC236}">
-                <a16:creationId xmlns:a16="http://schemas.microsoft.com/office/drawing/2014/main" id="{DF48D9E0-188D-3789-4EEE-36FD4B1C7FC4}"/>
+                <a16:creationId xmlns:a16="http://schemas.microsoft.com/office/drawing/2014/main" id="{B5468B02-C129-B64A-F6CF-0891EBB65221}"/>
               </a:ext>
             </a:extLst>
           </p:cNvPr>
@@ -7135,7 +7135,7 @@
           <p:cNvPr id="21" name="文本框 20">
             <a:extLst>
               <a:ext uri="{FF2B5EF4-FFF2-40B4-BE49-F238E27FC236}">
-                <a16:creationId xmlns:a16="http://schemas.microsoft.com/office/drawing/2014/main" id="{C629E014-59EB-84F0-8A17-54849983DC0A}"/>
+                <a16:creationId xmlns:a16="http://schemas.microsoft.com/office/drawing/2014/main" id="{BC0EB9E5-C181-2ED5-F84B-D9A3ED46A9FE}"/>
               </a:ext>
             </a:extLst>
           </p:cNvPr>
@@ -7196,7 +7196,7 @@
           <p:cNvPr id="22" name="矩形 21">
             <a:extLst>
               <a:ext uri="{FF2B5EF4-FFF2-40B4-BE49-F238E27FC236}">
-                <a16:creationId xmlns:a16="http://schemas.microsoft.com/office/drawing/2014/main" id="{743B4C28-EC43-2AB4-653E-63EE561E3221}"/>
+                <a16:creationId xmlns:a16="http://schemas.microsoft.com/office/drawing/2014/main" id="{77793010-0AFC-C85D-E534-9EF14C29987C}"/>
               </a:ext>
             </a:extLst>
           </p:cNvPr>
@@ -7264,7 +7264,7 @@
           <p:cNvPr id="23" name="文本框 22">
             <a:extLst>
               <a:ext uri="{FF2B5EF4-FFF2-40B4-BE49-F238E27FC236}">
-                <a16:creationId xmlns:a16="http://schemas.microsoft.com/office/drawing/2014/main" id="{8E4978E2-E22E-430B-01A8-6975ABD32DDE}"/>
+                <a16:creationId xmlns:a16="http://schemas.microsoft.com/office/drawing/2014/main" id="{6AAB2A16-DB72-7ED5-4AC8-14013104896C}"/>
               </a:ext>
             </a:extLst>
           </p:cNvPr>
@@ -7345,7 +7345,7 @@
           <p:cNvPr id="24" name="直接连接符 23">
             <a:extLst>
               <a:ext uri="{FF2B5EF4-FFF2-40B4-BE49-F238E27FC236}">
-                <a16:creationId xmlns:a16="http://schemas.microsoft.com/office/drawing/2014/main" id="{6F9429A0-607C-4CAD-21BD-684CBE7925A9}"/>
+                <a16:creationId xmlns:a16="http://schemas.microsoft.com/office/drawing/2014/main" id="{F276E626-1918-C94D-1D7B-3931DF71C890}"/>
               </a:ext>
             </a:extLst>
           </p:cNvPr>
@@ -7387,7 +7387,7 @@
             <a:hlinkClick r:id="rId6"/>
             <a:extLst>
               <a:ext uri="{FF2B5EF4-FFF2-40B4-BE49-F238E27FC236}">
-                <a16:creationId xmlns:a16="http://schemas.microsoft.com/office/drawing/2014/main" id="{271A32F9-A82A-14A6-2976-C450DBD5E050}"/>
+                <a16:creationId xmlns:a16="http://schemas.microsoft.com/office/drawing/2014/main" id="{334C6A37-B2A3-4B3B-31DD-52ABCA110E18}"/>
               </a:ext>
             </a:extLst>
           </p:cNvPr>
@@ -7516,7 +7516,7 @@
     </p:spTree>
     <p:extLst>
       <p:ext uri="{BB962C8B-B14F-4D97-AF65-F5344CB8AC3E}">
-        <p14:creationId xmlns:p14="http://schemas.microsoft.com/office/powerpoint/2010/main" val="443519870"/>
+        <p14:creationId xmlns:p14="http://schemas.microsoft.com/office/powerpoint/2010/main" val="854075082"/>
       </p:ext>
     </p:extLst>
   </p:cSld>
@@ -7556,7 +7556,7 @@
           <p:cNvPr id="2" name="矩形 1">
             <a:extLst>
               <a:ext uri="{FF2B5EF4-FFF2-40B4-BE49-F238E27FC236}">
-                <a16:creationId xmlns:a16="http://schemas.microsoft.com/office/drawing/2014/main" id="{4CA3B828-15CD-D9F7-F6B4-CF7BA9F00CD2}"/>
+                <a16:creationId xmlns:a16="http://schemas.microsoft.com/office/drawing/2014/main" id="{C3248377-E1AA-8560-A7BE-CB437BD6A009}"/>
               </a:ext>
             </a:extLst>
           </p:cNvPr>
@@ -7624,7 +7624,7 @@
           <p:cNvPr id="3" name="文本框 2">
             <a:extLst>
               <a:ext uri="{FF2B5EF4-FFF2-40B4-BE49-F238E27FC236}">
-                <a16:creationId xmlns:a16="http://schemas.microsoft.com/office/drawing/2014/main" id="{3683D5F2-7449-2884-B755-9FAF4B0236E0}"/>
+                <a16:creationId xmlns:a16="http://schemas.microsoft.com/office/drawing/2014/main" id="{A5E545C3-A0E6-0441-0C05-8DE746B201B6}"/>
               </a:ext>
             </a:extLst>
           </p:cNvPr>
@@ -7672,7 +7672,7 @@
           <p:cNvPr id="4" name="文本框 3">
             <a:extLst>
               <a:ext uri="{FF2B5EF4-FFF2-40B4-BE49-F238E27FC236}">
-                <a16:creationId xmlns:a16="http://schemas.microsoft.com/office/drawing/2014/main" id="{384D428B-ABFB-6BC6-BEA8-4182C0EBCC8C}"/>
+                <a16:creationId xmlns:a16="http://schemas.microsoft.com/office/drawing/2014/main" id="{6A42B157-ABA7-E7DC-79FF-69E9FF457586}"/>
               </a:ext>
             </a:extLst>
           </p:cNvPr>
@@ -7724,7 +7724,7 @@
           <p:cNvPr id="5" name="文本框 4">
             <a:extLst>
               <a:ext uri="{FF2B5EF4-FFF2-40B4-BE49-F238E27FC236}">
-                <a16:creationId xmlns:a16="http://schemas.microsoft.com/office/drawing/2014/main" id="{98879F1D-CEF5-BEB2-C74B-68861602FE4C}"/>
+                <a16:creationId xmlns:a16="http://schemas.microsoft.com/office/drawing/2014/main" id="{6680F02B-C9E0-7B8D-98A1-C32B124D0455}"/>
               </a:ext>
             </a:extLst>
           </p:cNvPr>
@@ -7825,7 +7825,7 @@
           <p:cNvPr id="6" name="文本框 5">
             <a:extLst>
               <a:ext uri="{FF2B5EF4-FFF2-40B4-BE49-F238E27FC236}">
-                <a16:creationId xmlns:a16="http://schemas.microsoft.com/office/drawing/2014/main" id="{44477F43-BDF0-1FFC-3166-28975C295A3E}"/>
+                <a16:creationId xmlns:a16="http://schemas.microsoft.com/office/drawing/2014/main" id="{A0257C82-5FB6-5AD1-F074-BE4A9EDFD9C4}"/>
               </a:ext>
             </a:extLst>
           </p:cNvPr>
@@ -7886,7 +7886,7 @@
           <p:cNvPr id="7" name="文本框 6">
             <a:extLst>
               <a:ext uri="{FF2B5EF4-FFF2-40B4-BE49-F238E27FC236}">
-                <a16:creationId xmlns:a16="http://schemas.microsoft.com/office/drawing/2014/main" id="{1D4D9575-03A7-244F-0AF7-F7A384D9E514}"/>
+                <a16:creationId xmlns:a16="http://schemas.microsoft.com/office/drawing/2014/main" id="{2D2B0A1B-059B-8001-09A1-855FBDB31B9E}"/>
               </a:ext>
             </a:extLst>
           </p:cNvPr>
@@ -7935,7 +7935,7 @@
           <p:cNvPr id="8" name="矩形 7">
             <a:extLst>
               <a:ext uri="{FF2B5EF4-FFF2-40B4-BE49-F238E27FC236}">
-                <a16:creationId xmlns:a16="http://schemas.microsoft.com/office/drawing/2014/main" id="{16FA27D4-27FE-ED79-F18A-5D323070EA81}"/>
+                <a16:creationId xmlns:a16="http://schemas.microsoft.com/office/drawing/2014/main" id="{D483B7BA-2600-A4CD-2951-CDBB81BC89B8}"/>
               </a:ext>
             </a:extLst>
           </p:cNvPr>
@@ -7989,7 +7989,7 @@
           <p:cNvPr id="9" name="文本框 8">
             <a:extLst>
               <a:ext uri="{FF2B5EF4-FFF2-40B4-BE49-F238E27FC236}">
-                <a16:creationId xmlns:a16="http://schemas.microsoft.com/office/drawing/2014/main" id="{8EB67A3E-16B6-89F3-705B-D86F4F1CC0FF}"/>
+                <a16:creationId xmlns:a16="http://schemas.microsoft.com/office/drawing/2014/main" id="{4BC0FAE3-173D-19AE-072B-BB794ECDA230}"/>
               </a:ext>
             </a:extLst>
           </p:cNvPr>
@@ -8050,7 +8050,7 @@
           <p:cNvPr id="10" name="文本框 9">
             <a:extLst>
               <a:ext uri="{FF2B5EF4-FFF2-40B4-BE49-F238E27FC236}">
-                <a16:creationId xmlns:a16="http://schemas.microsoft.com/office/drawing/2014/main" id="{368D3586-2503-373F-6177-A13F8D85740D}"/>
+                <a16:creationId xmlns:a16="http://schemas.microsoft.com/office/drawing/2014/main" id="{BFE98C61-8A01-8515-7B14-5ED09E73C372}"/>
               </a:ext>
             </a:extLst>
           </p:cNvPr>
@@ -8132,7 +8132,7 @@
           <p:cNvPr id="11" name="直接连接符 10">
             <a:extLst>
               <a:ext uri="{FF2B5EF4-FFF2-40B4-BE49-F238E27FC236}">
-                <a16:creationId xmlns:a16="http://schemas.microsoft.com/office/drawing/2014/main" id="{2337A4B9-05D5-FBA4-11F4-3F4423C27C8D}"/>
+                <a16:creationId xmlns:a16="http://schemas.microsoft.com/office/drawing/2014/main" id="{47B4CD81-F8A6-E3B8-2D70-FEBE52710BC9}"/>
               </a:ext>
             </a:extLst>
           </p:cNvPr>
@@ -8174,7 +8174,7 @@
           <p:cNvPr id="12" name="矩形 11">
             <a:extLst>
               <a:ext uri="{FF2B5EF4-FFF2-40B4-BE49-F238E27FC236}">
-                <a16:creationId xmlns:a16="http://schemas.microsoft.com/office/drawing/2014/main" id="{D1ED9F24-C8F5-2096-6153-78F5462576CB}"/>
+                <a16:creationId xmlns:a16="http://schemas.microsoft.com/office/drawing/2014/main" id="{8F7FEA56-2E99-B4F5-206E-291EB76F3614}"/>
               </a:ext>
             </a:extLst>
           </p:cNvPr>
@@ -8228,7 +8228,7 @@
           <p:cNvPr id="13" name="文本框 12">
             <a:extLst>
               <a:ext uri="{FF2B5EF4-FFF2-40B4-BE49-F238E27FC236}">
-                <a16:creationId xmlns:a16="http://schemas.microsoft.com/office/drawing/2014/main" id="{7D292E48-0C40-86FA-A10E-0351F14ED25D}"/>
+                <a16:creationId xmlns:a16="http://schemas.microsoft.com/office/drawing/2014/main" id="{46B4FD97-D337-ACC8-AF17-88F21ECE9C4F}"/>
               </a:ext>
             </a:extLst>
           </p:cNvPr>
@@ -8289,7 +8289,7 @@
           <p:cNvPr id="14" name="文本框 13">
             <a:extLst>
               <a:ext uri="{FF2B5EF4-FFF2-40B4-BE49-F238E27FC236}">
-                <a16:creationId xmlns:a16="http://schemas.microsoft.com/office/drawing/2014/main" id="{D1967020-8DA7-D029-CA29-16EEFDDE821C}"/>
+                <a16:creationId xmlns:a16="http://schemas.microsoft.com/office/drawing/2014/main" id="{9545D957-7E65-1617-91D7-FD5ED5B489D0}"/>
               </a:ext>
             </a:extLst>
           </p:cNvPr>
@@ -8331,7 +8331,7 @@
           <p:cNvPr id="15" name="直接连接符 14">
             <a:extLst>
               <a:ext uri="{FF2B5EF4-FFF2-40B4-BE49-F238E27FC236}">
-                <a16:creationId xmlns:a16="http://schemas.microsoft.com/office/drawing/2014/main" id="{D6FE3B71-F28D-D5CE-0648-3E15B0AC106B}"/>
+                <a16:creationId xmlns:a16="http://schemas.microsoft.com/office/drawing/2014/main" id="{B29B93C1-1F28-2EC2-8C92-766D9C2D79F3}"/>
               </a:ext>
             </a:extLst>
           </p:cNvPr>
@@ -8373,7 +8373,7 @@
           <p:cNvPr id="16" name="矩形 15">
             <a:extLst>
               <a:ext uri="{FF2B5EF4-FFF2-40B4-BE49-F238E27FC236}">
-                <a16:creationId xmlns:a16="http://schemas.microsoft.com/office/drawing/2014/main" id="{035503CE-1615-9461-D0A6-C8EF35151552}"/>
+                <a16:creationId xmlns:a16="http://schemas.microsoft.com/office/drawing/2014/main" id="{6412B1EB-489A-94F2-69E6-C595C5A2E549}"/>
               </a:ext>
             </a:extLst>
           </p:cNvPr>
@@ -8427,7 +8427,7 @@
           <p:cNvPr id="17" name="文本框 16">
             <a:extLst>
               <a:ext uri="{FF2B5EF4-FFF2-40B4-BE49-F238E27FC236}">
-                <a16:creationId xmlns:a16="http://schemas.microsoft.com/office/drawing/2014/main" id="{C2DD6DA1-3E87-67DF-9F62-D8BE4A650773}"/>
+                <a16:creationId xmlns:a16="http://schemas.microsoft.com/office/drawing/2014/main" id="{2A509BCC-4123-DBDE-2F70-E777EE3DB3CD}"/>
               </a:ext>
             </a:extLst>
           </p:cNvPr>
@@ -8485,7 +8485,7 @@
           <p:cNvPr id="18" name="文本框 17">
             <a:extLst>
               <a:ext uri="{FF2B5EF4-FFF2-40B4-BE49-F238E27FC236}">
-                <a16:creationId xmlns:a16="http://schemas.microsoft.com/office/drawing/2014/main" id="{82929D67-99FD-2B5F-3FD4-AEC808C8F5DF}"/>
+                <a16:creationId xmlns:a16="http://schemas.microsoft.com/office/drawing/2014/main" id="{CBDB43CB-E861-AAFB-F784-D662BFC68167}"/>
               </a:ext>
             </a:extLst>
           </p:cNvPr>
@@ -8547,7 +8547,7 @@
           <p:cNvPr id="19" name="矩形 18">
             <a:extLst>
               <a:ext uri="{FF2B5EF4-FFF2-40B4-BE49-F238E27FC236}">
-                <a16:creationId xmlns:a16="http://schemas.microsoft.com/office/drawing/2014/main" id="{54512FAC-BD32-6ABB-7F98-5AAF9A81BE3D}"/>
+                <a16:creationId xmlns:a16="http://schemas.microsoft.com/office/drawing/2014/main" id="{FD416E97-9711-02E1-D2DD-0B9C957BAAA2}"/>
               </a:ext>
             </a:extLst>
           </p:cNvPr>
@@ -8601,7 +8601,7 @@
           <p:cNvPr id="20" name="文本框 19">
             <a:extLst>
               <a:ext uri="{FF2B5EF4-FFF2-40B4-BE49-F238E27FC236}">
-                <a16:creationId xmlns:a16="http://schemas.microsoft.com/office/drawing/2014/main" id="{FA331CEC-D865-62E0-29C2-9789C2D540CD}"/>
+                <a16:creationId xmlns:a16="http://schemas.microsoft.com/office/drawing/2014/main" id="{0C8E69F4-7D1C-C36C-CFCF-12EC75F5BD8E}"/>
               </a:ext>
             </a:extLst>
           </p:cNvPr>
@@ -8642,7 +8642,7 @@
           <p:cNvPr id="21" name="文本框 20">
             <a:extLst>
               <a:ext uri="{FF2B5EF4-FFF2-40B4-BE49-F238E27FC236}">
-                <a16:creationId xmlns:a16="http://schemas.microsoft.com/office/drawing/2014/main" id="{BEDE8835-A563-5EF2-BD8D-84123CCABAFA}"/>
+                <a16:creationId xmlns:a16="http://schemas.microsoft.com/office/drawing/2014/main" id="{CF6233E5-C831-DD89-F4B8-9D5C9DF65519}"/>
               </a:ext>
             </a:extLst>
           </p:cNvPr>
@@ -8730,7 +8730,7 @@
           <p:cNvPr id="22" name="文本框 21">
             <a:extLst>
               <a:ext uri="{FF2B5EF4-FFF2-40B4-BE49-F238E27FC236}">
-                <a16:creationId xmlns:a16="http://schemas.microsoft.com/office/drawing/2014/main" id="{600FF289-584E-7B19-4447-08677302AA23}"/>
+                <a16:creationId xmlns:a16="http://schemas.microsoft.com/office/drawing/2014/main" id="{69E41173-1BDA-2563-AF01-6A91E689D83E}"/>
               </a:ext>
             </a:extLst>
           </p:cNvPr>
@@ -8818,7 +8818,7 @@
           <p:cNvPr id="23" name="矩形 22">
             <a:extLst>
               <a:ext uri="{FF2B5EF4-FFF2-40B4-BE49-F238E27FC236}">
-                <a16:creationId xmlns:a16="http://schemas.microsoft.com/office/drawing/2014/main" id="{0BEEB252-D1C5-2CD1-2C7B-752C4D2F3FDB}"/>
+                <a16:creationId xmlns:a16="http://schemas.microsoft.com/office/drawing/2014/main" id="{49AC0CD0-5069-B29A-92AE-A3A36935778B}"/>
               </a:ext>
             </a:extLst>
           </p:cNvPr>
@@ -8872,7 +8872,7 @@
           <p:cNvPr id="24" name="文本框 23">
             <a:extLst>
               <a:ext uri="{FF2B5EF4-FFF2-40B4-BE49-F238E27FC236}">
-                <a16:creationId xmlns:a16="http://schemas.microsoft.com/office/drawing/2014/main" id="{58946513-AD0F-DC5A-3A53-70B65C8FB4B0}"/>
+                <a16:creationId xmlns:a16="http://schemas.microsoft.com/office/drawing/2014/main" id="{97AE1640-04FE-9679-24FC-127931A6B1EA}"/>
               </a:ext>
             </a:extLst>
           </p:cNvPr>
@@ -8923,7 +8923,7 @@
           <p:cNvPr id="25" name="文本框 24">
             <a:extLst>
               <a:ext uri="{FF2B5EF4-FFF2-40B4-BE49-F238E27FC236}">
-                <a16:creationId xmlns:a16="http://schemas.microsoft.com/office/drawing/2014/main" id="{DB9100EF-5ACA-4743-557C-421B29EC89E1}"/>
+                <a16:creationId xmlns:a16="http://schemas.microsoft.com/office/drawing/2014/main" id="{0FC54040-E640-C8AB-B195-B463029C8515}"/>
               </a:ext>
             </a:extLst>
           </p:cNvPr>
@@ -8994,7 +8994,7 @@
           <p:cNvPr id="26" name="文本框 25">
             <a:extLst>
               <a:ext uri="{FF2B5EF4-FFF2-40B4-BE49-F238E27FC236}">
-                <a16:creationId xmlns:a16="http://schemas.microsoft.com/office/drawing/2014/main" id="{24DF711F-779E-0F28-1EDE-174E2CACD568}"/>
+                <a16:creationId xmlns:a16="http://schemas.microsoft.com/office/drawing/2014/main" id="{4B169D5C-15AA-BA01-A482-3DC64F0F5F58}"/>
               </a:ext>
             </a:extLst>
           </p:cNvPr>
@@ -9075,7 +9075,7 @@
           <p:cNvPr id="27" name="矩形 26">
             <a:extLst>
               <a:ext uri="{FF2B5EF4-FFF2-40B4-BE49-F238E27FC236}">
-                <a16:creationId xmlns:a16="http://schemas.microsoft.com/office/drawing/2014/main" id="{D1FEE37B-77E2-78DD-694C-9DCA92AEAA21}"/>
+                <a16:creationId xmlns:a16="http://schemas.microsoft.com/office/drawing/2014/main" id="{484DE01C-F4EA-9A8A-B762-543FE15A197B}"/>
               </a:ext>
             </a:extLst>
           </p:cNvPr>
@@ -9143,7 +9143,7 @@
           <p:cNvPr id="28" name="文本框 27">
             <a:extLst>
               <a:ext uri="{FF2B5EF4-FFF2-40B4-BE49-F238E27FC236}">
-                <a16:creationId xmlns:a16="http://schemas.microsoft.com/office/drawing/2014/main" id="{0189FE7A-E24B-BDBC-8B74-E44984CD1530}"/>
+                <a16:creationId xmlns:a16="http://schemas.microsoft.com/office/drawing/2014/main" id="{5249FBDC-087C-6DD4-2CC2-9D4945D262B3}"/>
               </a:ext>
             </a:extLst>
           </p:cNvPr>
@@ -9244,7 +9244,7 @@
           <p:cNvPr id="29" name="直接连接符 28">
             <a:extLst>
               <a:ext uri="{FF2B5EF4-FFF2-40B4-BE49-F238E27FC236}">
-                <a16:creationId xmlns:a16="http://schemas.microsoft.com/office/drawing/2014/main" id="{DB7FE1E7-29FF-274C-E515-2FC5383BBFD6}"/>
+                <a16:creationId xmlns:a16="http://schemas.microsoft.com/office/drawing/2014/main" id="{058F434F-3531-CB9F-7F47-2ABC3CD09DE9}"/>
               </a:ext>
             </a:extLst>
           </p:cNvPr>
@@ -9286,7 +9286,7 @@
             <a:hlinkClick r:id="rId3"/>
             <a:extLst>
               <a:ext uri="{FF2B5EF4-FFF2-40B4-BE49-F238E27FC236}">
-                <a16:creationId xmlns:a16="http://schemas.microsoft.com/office/drawing/2014/main" id="{57DC6279-4E1B-9F96-A01C-18A42BF5D4B5}"/>
+                <a16:creationId xmlns:a16="http://schemas.microsoft.com/office/drawing/2014/main" id="{C1588062-3316-896D-37B6-092795DBA257}"/>
               </a:ext>
             </a:extLst>
           </p:cNvPr>
@@ -9405,7 +9405,7 @@
     </p:spTree>
     <p:extLst>
       <p:ext uri="{BB962C8B-B14F-4D97-AF65-F5344CB8AC3E}">
-        <p14:creationId xmlns:p14="http://schemas.microsoft.com/office/powerpoint/2010/main" val="3740247880"/>
+        <p14:creationId xmlns:p14="http://schemas.microsoft.com/office/powerpoint/2010/main" val="709750329"/>
       </p:ext>
     </p:extLst>
   </p:cSld>
@@ -9445,7 +9445,7 @@
           <p:cNvPr id="2" name="矩形 1">
             <a:extLst>
               <a:ext uri="{FF2B5EF4-FFF2-40B4-BE49-F238E27FC236}">
-                <a16:creationId xmlns:a16="http://schemas.microsoft.com/office/drawing/2014/main" id="{C9947A2D-022D-A396-BB26-8A8E514DB104}"/>
+                <a16:creationId xmlns:a16="http://schemas.microsoft.com/office/drawing/2014/main" id="{C98B050D-84D1-A279-D41D-39C28C08D2B7}"/>
               </a:ext>
             </a:extLst>
           </p:cNvPr>
@@ -9513,7 +9513,7 @@
           <p:cNvPr id="3" name="文本框 2">
             <a:extLst>
               <a:ext uri="{FF2B5EF4-FFF2-40B4-BE49-F238E27FC236}">
-                <a16:creationId xmlns:a16="http://schemas.microsoft.com/office/drawing/2014/main" id="{E3237DC4-6824-571A-ACB6-DF209B91F8C1}"/>
+                <a16:creationId xmlns:a16="http://schemas.microsoft.com/office/drawing/2014/main" id="{571AB97D-EE6B-D07C-7B8C-9690317454BA}"/>
               </a:ext>
             </a:extLst>
           </p:cNvPr>
@@ -9561,7 +9561,7 @@
           <p:cNvPr id="4" name="文本框 3">
             <a:extLst>
               <a:ext uri="{FF2B5EF4-FFF2-40B4-BE49-F238E27FC236}">
-                <a16:creationId xmlns:a16="http://schemas.microsoft.com/office/drawing/2014/main" id="{03DFAD45-97B3-5167-630A-FC3F7BA2F0D2}"/>
+                <a16:creationId xmlns:a16="http://schemas.microsoft.com/office/drawing/2014/main" id="{2F240E8B-76C7-F18B-0EE4-27FC8B86F55A}"/>
               </a:ext>
             </a:extLst>
           </p:cNvPr>
@@ -9613,7 +9613,7 @@
           <p:cNvPr id="5" name="文本框 4">
             <a:extLst>
               <a:ext uri="{FF2B5EF4-FFF2-40B4-BE49-F238E27FC236}">
-                <a16:creationId xmlns:a16="http://schemas.microsoft.com/office/drawing/2014/main" id="{631B4488-C87B-CC3B-C8BD-EE0D67EE0562}"/>
+                <a16:creationId xmlns:a16="http://schemas.microsoft.com/office/drawing/2014/main" id="{8672242A-F5A4-A9ED-3BC4-EE0BE5B99020}"/>
               </a:ext>
             </a:extLst>
           </p:cNvPr>
@@ -9654,7 +9654,7 @@
           <p:cNvPr id="6" name="文本框 5">
             <a:extLst>
               <a:ext uri="{FF2B5EF4-FFF2-40B4-BE49-F238E27FC236}">
-                <a16:creationId xmlns:a16="http://schemas.microsoft.com/office/drawing/2014/main" id="{F250E11E-81FB-C9C3-DFFA-E48294C07B0B}"/>
+                <a16:creationId xmlns:a16="http://schemas.microsoft.com/office/drawing/2014/main" id="{760C6D57-3632-000A-75DF-94A47AC37BDB}"/>
               </a:ext>
             </a:extLst>
           </p:cNvPr>
@@ -9752,7 +9752,7 @@
           <p:cNvPr id="7" name="文本框 6">
             <a:extLst>
               <a:ext uri="{FF2B5EF4-FFF2-40B4-BE49-F238E27FC236}">
-                <a16:creationId xmlns:a16="http://schemas.microsoft.com/office/drawing/2014/main" id="{685709E0-ADE0-7CC3-6EC7-CB7755A59D60}"/>
+                <a16:creationId xmlns:a16="http://schemas.microsoft.com/office/drawing/2014/main" id="{86148307-AC3A-C451-F59C-5B29D8F11DE4}"/>
               </a:ext>
             </a:extLst>
           </p:cNvPr>
@@ -9801,7 +9801,7 @@
           <p:cNvPr id="8" name="文本框 7">
             <a:extLst>
               <a:ext uri="{FF2B5EF4-FFF2-40B4-BE49-F238E27FC236}">
-                <a16:creationId xmlns:a16="http://schemas.microsoft.com/office/drawing/2014/main" id="{6B2006F9-7E06-CE20-17AF-5C831E0AFDBD}"/>
+                <a16:creationId xmlns:a16="http://schemas.microsoft.com/office/drawing/2014/main" id="{653BCCAE-D5D0-E690-95D6-BEEC3CB126EE}"/>
               </a:ext>
             </a:extLst>
           </p:cNvPr>
@@ -9859,7 +9859,7 @@
           <p:cNvPr id="9" name="文本框 8">
             <a:extLst>
               <a:ext uri="{FF2B5EF4-FFF2-40B4-BE49-F238E27FC236}">
-                <a16:creationId xmlns:a16="http://schemas.microsoft.com/office/drawing/2014/main" id="{3B4EC88A-7235-4A22-19C9-8903D94FA5DF}"/>
+                <a16:creationId xmlns:a16="http://schemas.microsoft.com/office/drawing/2014/main" id="{2D6F7277-6E4D-5E36-12F2-446BC3D1AFDA}"/>
               </a:ext>
             </a:extLst>
           </p:cNvPr>
@@ -9917,7 +9917,7 @@
           <p:cNvPr id="10" name="文本框 9">
             <a:extLst>
               <a:ext uri="{FF2B5EF4-FFF2-40B4-BE49-F238E27FC236}">
-                <a16:creationId xmlns:a16="http://schemas.microsoft.com/office/drawing/2014/main" id="{F83F288A-9D2E-889F-81F5-4F20704EA9F5}"/>
+                <a16:creationId xmlns:a16="http://schemas.microsoft.com/office/drawing/2014/main" id="{11AB2BF9-C2EA-2E07-617A-7FB5255776FF}"/>
               </a:ext>
             </a:extLst>
           </p:cNvPr>
@@ -9985,7 +9985,7 @@
           <p:cNvPr id="12" name="图片 11">
             <a:extLst>
               <a:ext uri="{FF2B5EF4-FFF2-40B4-BE49-F238E27FC236}">
-                <a16:creationId xmlns:a16="http://schemas.microsoft.com/office/drawing/2014/main" id="{C6380784-5638-9B01-6DAB-1A6424E29688}"/>
+                <a16:creationId xmlns:a16="http://schemas.microsoft.com/office/drawing/2014/main" id="{DB6EEE0F-0AD7-0C7B-6895-E3BEF86603EA}"/>
               </a:ext>
             </a:extLst>
           </p:cNvPr>
@@ -10021,7 +10021,7 @@
           <p:cNvPr id="14" name="图片 13">
             <a:extLst>
               <a:ext uri="{FF2B5EF4-FFF2-40B4-BE49-F238E27FC236}">
-                <a16:creationId xmlns:a16="http://schemas.microsoft.com/office/drawing/2014/main" id="{813B56E2-5F84-30E7-E6BE-DECB419F9A57}"/>
+                <a16:creationId xmlns:a16="http://schemas.microsoft.com/office/drawing/2014/main" id="{A9848829-C53E-6AC3-7039-040FB9632C8B}"/>
               </a:ext>
             </a:extLst>
           </p:cNvPr>
@@ -10057,7 +10057,7 @@
           <p:cNvPr id="16" name="图片 15">
             <a:extLst>
               <a:ext uri="{FF2B5EF4-FFF2-40B4-BE49-F238E27FC236}">
-                <a16:creationId xmlns:a16="http://schemas.microsoft.com/office/drawing/2014/main" id="{39314CE5-ECBF-0D92-8078-ACF8D36B68BF}"/>
+                <a16:creationId xmlns:a16="http://schemas.microsoft.com/office/drawing/2014/main" id="{D25D5457-B26C-BE07-7A1A-D52AACB3403D}"/>
               </a:ext>
             </a:extLst>
           </p:cNvPr>
@@ -10093,7 +10093,7 @@
           <p:cNvPr id="17" name="文本框 16">
             <a:extLst>
               <a:ext uri="{FF2B5EF4-FFF2-40B4-BE49-F238E27FC236}">
-                <a16:creationId xmlns:a16="http://schemas.microsoft.com/office/drawing/2014/main" id="{53DCBA5A-F7D0-BCD8-E91F-DF4E23CEAAD0}"/>
+                <a16:creationId xmlns:a16="http://schemas.microsoft.com/office/drawing/2014/main" id="{7CB88FEA-4C32-28BB-DE84-5938AF014190}"/>
               </a:ext>
             </a:extLst>
           </p:cNvPr>
@@ -10142,7 +10142,7 @@
           <p:cNvPr id="18" name="直接连接符 17">
             <a:extLst>
               <a:ext uri="{FF2B5EF4-FFF2-40B4-BE49-F238E27FC236}">
-                <a16:creationId xmlns:a16="http://schemas.microsoft.com/office/drawing/2014/main" id="{5815FFA7-14E8-AE07-061F-4C9AE9180718}"/>
+                <a16:creationId xmlns:a16="http://schemas.microsoft.com/office/drawing/2014/main" id="{9680CDA8-34D6-5D18-FDB3-C3C3B1565598}"/>
               </a:ext>
             </a:extLst>
           </p:cNvPr>
@@ -10184,7 +10184,7 @@
           <p:cNvPr id="19" name="文本框 18">
             <a:extLst>
               <a:ext uri="{FF2B5EF4-FFF2-40B4-BE49-F238E27FC236}">
-                <a16:creationId xmlns:a16="http://schemas.microsoft.com/office/drawing/2014/main" id="{0EE282A1-8D61-7A6F-C401-A6BFDE8FC0F0}"/>
+                <a16:creationId xmlns:a16="http://schemas.microsoft.com/office/drawing/2014/main" id="{18909DB8-4CA5-75B0-7854-A4C9C56AF588}"/>
               </a:ext>
             </a:extLst>
           </p:cNvPr>
@@ -10265,7 +10265,7 @@
           <p:cNvPr id="20" name="文本框 19">
             <a:extLst>
               <a:ext uri="{FF2B5EF4-FFF2-40B4-BE49-F238E27FC236}">
-                <a16:creationId xmlns:a16="http://schemas.microsoft.com/office/drawing/2014/main" id="{B399673E-1805-42DA-B707-88ED34A0AD02}"/>
+                <a16:creationId xmlns:a16="http://schemas.microsoft.com/office/drawing/2014/main" id="{13B208EA-7C2F-0255-FFD2-1FEFC0B08D9D}"/>
               </a:ext>
             </a:extLst>
           </p:cNvPr>
@@ -10346,7 +10346,7 @@
           <p:cNvPr id="21" name="文本框 20">
             <a:extLst>
               <a:ext uri="{FF2B5EF4-FFF2-40B4-BE49-F238E27FC236}">
-                <a16:creationId xmlns:a16="http://schemas.microsoft.com/office/drawing/2014/main" id="{A758EC32-C50E-CB3A-A96A-B46910C8F471}"/>
+                <a16:creationId xmlns:a16="http://schemas.microsoft.com/office/drawing/2014/main" id="{A7AFB0E1-B1CB-128D-6346-52267303BB2E}"/>
               </a:ext>
             </a:extLst>
           </p:cNvPr>
@@ -10407,7 +10407,7 @@
           <p:cNvPr id="22" name="矩形 21">
             <a:extLst>
               <a:ext uri="{FF2B5EF4-FFF2-40B4-BE49-F238E27FC236}">
-                <a16:creationId xmlns:a16="http://schemas.microsoft.com/office/drawing/2014/main" id="{31F6D2BB-AB36-9E8A-A1B9-EF0B59AE6F84}"/>
+                <a16:creationId xmlns:a16="http://schemas.microsoft.com/office/drawing/2014/main" id="{1F7263A6-A6C7-8539-1424-58889444D4AA}"/>
               </a:ext>
             </a:extLst>
           </p:cNvPr>
@@ -10475,7 +10475,7 @@
           <p:cNvPr id="23" name="文本框 22">
             <a:extLst>
               <a:ext uri="{FF2B5EF4-FFF2-40B4-BE49-F238E27FC236}">
-                <a16:creationId xmlns:a16="http://schemas.microsoft.com/office/drawing/2014/main" id="{73BB8E28-0BC2-E9D5-6B16-D0AC77AF1BB6}"/>
+                <a16:creationId xmlns:a16="http://schemas.microsoft.com/office/drawing/2014/main" id="{639027EE-7890-BC99-5330-0A92B819F875}"/>
               </a:ext>
             </a:extLst>
           </p:cNvPr>
@@ -10516,7 +10516,7 @@
           <p:cNvPr id="24" name="直接连接符 23">
             <a:extLst>
               <a:ext uri="{FF2B5EF4-FFF2-40B4-BE49-F238E27FC236}">
-                <a16:creationId xmlns:a16="http://schemas.microsoft.com/office/drawing/2014/main" id="{21641F07-0EE5-CBE7-1130-5C37C1BE85CE}"/>
+                <a16:creationId xmlns:a16="http://schemas.microsoft.com/office/drawing/2014/main" id="{F9D4A91D-BF8F-B3D0-CC83-06403DBBF2AF}"/>
               </a:ext>
             </a:extLst>
           </p:cNvPr>
@@ -10558,7 +10558,7 @@
             <a:hlinkClick r:id="rId6"/>
             <a:extLst>
               <a:ext uri="{FF2B5EF4-FFF2-40B4-BE49-F238E27FC236}">
-                <a16:creationId xmlns:a16="http://schemas.microsoft.com/office/drawing/2014/main" id="{6D942DE2-DD9F-7D4C-2AE2-0AA749714333}"/>
+                <a16:creationId xmlns:a16="http://schemas.microsoft.com/office/drawing/2014/main" id="{4F531FA3-BFEF-D0A3-2D20-FB2C64BFA3BE}"/>
               </a:ext>
             </a:extLst>
           </p:cNvPr>
@@ -10687,7 +10687,7 @@
     </p:spTree>
     <p:extLst>
       <p:ext uri="{BB962C8B-B14F-4D97-AF65-F5344CB8AC3E}">
-        <p14:creationId xmlns:p14="http://schemas.microsoft.com/office/powerpoint/2010/main" val="1826974445"/>
+        <p14:creationId xmlns:p14="http://schemas.microsoft.com/office/powerpoint/2010/main" val="3910141352"/>
       </p:ext>
     </p:extLst>
   </p:cSld>
@@ -10727,7 +10727,7 @@
           <p:cNvPr id="2" name="矩形 1">
             <a:extLst>
               <a:ext uri="{FF2B5EF4-FFF2-40B4-BE49-F238E27FC236}">
-                <a16:creationId xmlns:a16="http://schemas.microsoft.com/office/drawing/2014/main" id="{9E098058-4E8C-5141-9E9E-3C718318AE29}"/>
+                <a16:creationId xmlns:a16="http://schemas.microsoft.com/office/drawing/2014/main" id="{E67679C3-7144-B995-99D5-57FC22AD9D17}"/>
               </a:ext>
             </a:extLst>
           </p:cNvPr>
@@ -10795,7 +10795,7 @@
           <p:cNvPr id="3" name="文本框 2">
             <a:extLst>
               <a:ext uri="{FF2B5EF4-FFF2-40B4-BE49-F238E27FC236}">
-                <a16:creationId xmlns:a16="http://schemas.microsoft.com/office/drawing/2014/main" id="{FF83D5F3-1DBB-ECCA-D45D-552D1799641E}"/>
+                <a16:creationId xmlns:a16="http://schemas.microsoft.com/office/drawing/2014/main" id="{D58DC71E-B8F2-8113-151E-B15717F91A84}"/>
               </a:ext>
             </a:extLst>
           </p:cNvPr>
@@ -10843,7 +10843,7 @@
           <p:cNvPr id="4" name="文本框 3">
             <a:extLst>
               <a:ext uri="{FF2B5EF4-FFF2-40B4-BE49-F238E27FC236}">
-                <a16:creationId xmlns:a16="http://schemas.microsoft.com/office/drawing/2014/main" id="{64A5558A-DCCA-8611-13EA-60E88EF2D3F4}"/>
+                <a16:creationId xmlns:a16="http://schemas.microsoft.com/office/drawing/2014/main" id="{6D8BD2B2-0E04-CEC4-A611-7D85B2EDACC5}"/>
               </a:ext>
             </a:extLst>
           </p:cNvPr>
@@ -10895,7 +10895,7 @@
           <p:cNvPr id="5" name="文本框 4">
             <a:extLst>
               <a:ext uri="{FF2B5EF4-FFF2-40B4-BE49-F238E27FC236}">
-                <a16:creationId xmlns:a16="http://schemas.microsoft.com/office/drawing/2014/main" id="{7A77C12C-B1CA-2226-7590-DE0DBE0632F1}"/>
+                <a16:creationId xmlns:a16="http://schemas.microsoft.com/office/drawing/2014/main" id="{A4EB6C41-7CA5-7DE3-BB94-DB5FC2E8DA1C}"/>
               </a:ext>
             </a:extLst>
           </p:cNvPr>
@@ -10936,7 +10936,7 @@
           <p:cNvPr id="6" name="文本框 5">
             <a:extLst>
               <a:ext uri="{FF2B5EF4-FFF2-40B4-BE49-F238E27FC236}">
-                <a16:creationId xmlns:a16="http://schemas.microsoft.com/office/drawing/2014/main" id="{9DF7E588-76F1-38ED-1BA7-0A74CAC2B25A}"/>
+                <a16:creationId xmlns:a16="http://schemas.microsoft.com/office/drawing/2014/main" id="{3EFB0B94-1C8E-BFC8-3136-9347AF170A99}"/>
               </a:ext>
             </a:extLst>
           </p:cNvPr>
@@ -11007,7 +11007,7 @@
           <p:cNvPr id="7" name="文本框 6">
             <a:extLst>
               <a:ext uri="{FF2B5EF4-FFF2-40B4-BE49-F238E27FC236}">
-                <a16:creationId xmlns:a16="http://schemas.microsoft.com/office/drawing/2014/main" id="{ED33633A-5052-0963-5FEC-A0E61ED1806B}"/>
+                <a16:creationId xmlns:a16="http://schemas.microsoft.com/office/drawing/2014/main" id="{2DE2FA0A-C704-C02A-1FB6-F880103C112B}"/>
               </a:ext>
             </a:extLst>
           </p:cNvPr>
@@ -11056,7 +11056,7 @@
           <p:cNvPr id="8" name="矩形 7">
             <a:extLst>
               <a:ext uri="{FF2B5EF4-FFF2-40B4-BE49-F238E27FC236}">
-                <a16:creationId xmlns:a16="http://schemas.microsoft.com/office/drawing/2014/main" id="{FEA8077D-E1EE-5511-BDFA-18B846113742}"/>
+                <a16:creationId xmlns:a16="http://schemas.microsoft.com/office/drawing/2014/main" id="{0EA149BF-106F-6471-4AC6-EFB1A220A82C}"/>
               </a:ext>
             </a:extLst>
           </p:cNvPr>
@@ -11110,7 +11110,7 @@
           <p:cNvPr id="9" name="文本框 8">
             <a:extLst>
               <a:ext uri="{FF2B5EF4-FFF2-40B4-BE49-F238E27FC236}">
-                <a16:creationId xmlns:a16="http://schemas.microsoft.com/office/drawing/2014/main" id="{6C3C5D2F-149E-43A1-E5D4-79596FDFF9C4}"/>
+                <a16:creationId xmlns:a16="http://schemas.microsoft.com/office/drawing/2014/main" id="{65249058-7609-7600-BC3D-FB04AE1119C0}"/>
               </a:ext>
             </a:extLst>
           </p:cNvPr>
@@ -11171,7 +11171,7 @@
           <p:cNvPr id="10" name="文本框 9">
             <a:extLst>
               <a:ext uri="{FF2B5EF4-FFF2-40B4-BE49-F238E27FC236}">
-                <a16:creationId xmlns:a16="http://schemas.microsoft.com/office/drawing/2014/main" id="{76D26802-F611-CF91-5244-62F1936A3E18}"/>
+                <a16:creationId xmlns:a16="http://schemas.microsoft.com/office/drawing/2014/main" id="{B93C6C1D-9A9B-4143-F260-FA78EB9D2762}"/>
               </a:ext>
             </a:extLst>
           </p:cNvPr>
@@ -11212,7 +11212,7 @@
           <p:cNvPr id="11" name="直接连接符 10">
             <a:extLst>
               <a:ext uri="{FF2B5EF4-FFF2-40B4-BE49-F238E27FC236}">
-                <a16:creationId xmlns:a16="http://schemas.microsoft.com/office/drawing/2014/main" id="{2AB2CD09-9E4D-72F5-83CF-543FAD38F859}"/>
+                <a16:creationId xmlns:a16="http://schemas.microsoft.com/office/drawing/2014/main" id="{AAFC58FF-D55D-FDFD-48C3-B13BC0E54775}"/>
               </a:ext>
             </a:extLst>
           </p:cNvPr>
@@ -11254,7 +11254,7 @@
           <p:cNvPr id="12" name="直接连接符 11">
             <a:extLst>
               <a:ext uri="{FF2B5EF4-FFF2-40B4-BE49-F238E27FC236}">
-                <a16:creationId xmlns:a16="http://schemas.microsoft.com/office/drawing/2014/main" id="{93A4B05D-41C3-E8EF-3BCA-D80461FCC8D0}"/>
+                <a16:creationId xmlns:a16="http://schemas.microsoft.com/office/drawing/2014/main" id="{06E181E4-B6E0-92DC-CA92-22499A750391}"/>
               </a:ext>
             </a:extLst>
           </p:cNvPr>
@@ -11296,7 +11296,7 @@
           <p:cNvPr id="13" name="矩形 12">
             <a:extLst>
               <a:ext uri="{FF2B5EF4-FFF2-40B4-BE49-F238E27FC236}">
-                <a16:creationId xmlns:a16="http://schemas.microsoft.com/office/drawing/2014/main" id="{7CEED1CF-D938-D4EE-D272-A5E66BD528FD}"/>
+                <a16:creationId xmlns:a16="http://schemas.microsoft.com/office/drawing/2014/main" id="{59E69019-6D1E-9749-0154-740930ABF410}"/>
               </a:ext>
             </a:extLst>
           </p:cNvPr>
@@ -11364,7 +11364,7 @@
           <p:cNvPr id="14" name="文本框 13">
             <a:extLst>
               <a:ext uri="{FF2B5EF4-FFF2-40B4-BE49-F238E27FC236}">
-                <a16:creationId xmlns:a16="http://schemas.microsoft.com/office/drawing/2014/main" id="{0E3AD66E-8A4A-80B2-4200-84B1EA7D2067}"/>
+                <a16:creationId xmlns:a16="http://schemas.microsoft.com/office/drawing/2014/main" id="{58A8CF97-B443-017D-6B0A-A3DE212F3046}"/>
               </a:ext>
             </a:extLst>
           </p:cNvPr>
@@ -11472,7 +11472,7 @@
           <p:cNvPr id="15" name="矩形 14">
             <a:extLst>
               <a:ext uri="{FF2B5EF4-FFF2-40B4-BE49-F238E27FC236}">
-                <a16:creationId xmlns:a16="http://schemas.microsoft.com/office/drawing/2014/main" id="{C4E421C4-1AB4-0462-7432-048071BA2042}"/>
+                <a16:creationId xmlns:a16="http://schemas.microsoft.com/office/drawing/2014/main" id="{8F0D9678-3C03-5491-923D-92FD0D168E2F}"/>
               </a:ext>
             </a:extLst>
           </p:cNvPr>
@@ -11540,7 +11540,7 @@
           <p:cNvPr id="16" name="文本框 15">
             <a:extLst>
               <a:ext uri="{FF2B5EF4-FFF2-40B4-BE49-F238E27FC236}">
-                <a16:creationId xmlns:a16="http://schemas.microsoft.com/office/drawing/2014/main" id="{BBD74D21-B73C-9177-464D-723AACC7A1CE}"/>
+                <a16:creationId xmlns:a16="http://schemas.microsoft.com/office/drawing/2014/main" id="{1099F56E-19F1-09C2-7C98-250AA4F4AA31}"/>
               </a:ext>
             </a:extLst>
           </p:cNvPr>
@@ -11648,7 +11648,7 @@
           <p:cNvPr id="17" name="文本框 16">
             <a:extLst>
               <a:ext uri="{FF2B5EF4-FFF2-40B4-BE49-F238E27FC236}">
-                <a16:creationId xmlns:a16="http://schemas.microsoft.com/office/drawing/2014/main" id="{BF9E21FC-9BEF-B71F-3066-091EAD1A34DB}"/>
+                <a16:creationId xmlns:a16="http://schemas.microsoft.com/office/drawing/2014/main" id="{18ED7783-D999-F4BF-8860-225D01C856CC}"/>
               </a:ext>
             </a:extLst>
           </p:cNvPr>
@@ -11689,7 +11689,7 @@
           <p:cNvPr id="18" name="文本框 17">
             <a:extLst>
               <a:ext uri="{FF2B5EF4-FFF2-40B4-BE49-F238E27FC236}">
-                <a16:creationId xmlns:a16="http://schemas.microsoft.com/office/drawing/2014/main" id="{D348BD59-A03F-D005-1640-DEBD9AF87A5A}"/>
+                <a16:creationId xmlns:a16="http://schemas.microsoft.com/office/drawing/2014/main" id="{2EE55667-D8AD-3AEA-AE25-D3928C7C299D}"/>
               </a:ext>
             </a:extLst>
           </p:cNvPr>
@@ -11730,7 +11730,7 @@
           <p:cNvPr id="19" name="文本框 18">
             <a:extLst>
               <a:ext uri="{FF2B5EF4-FFF2-40B4-BE49-F238E27FC236}">
-                <a16:creationId xmlns:a16="http://schemas.microsoft.com/office/drawing/2014/main" id="{7C2001DA-2968-2FA9-8C67-A5E400C34E8A}"/>
+                <a16:creationId xmlns:a16="http://schemas.microsoft.com/office/drawing/2014/main" id="{85456E07-6B3A-8E7D-03A7-66DF68820968}"/>
               </a:ext>
             </a:extLst>
           </p:cNvPr>
@@ -11778,7 +11778,7 @@
           <p:cNvPr id="20" name="矩形 19">
             <a:extLst>
               <a:ext uri="{FF2B5EF4-FFF2-40B4-BE49-F238E27FC236}">
-                <a16:creationId xmlns:a16="http://schemas.microsoft.com/office/drawing/2014/main" id="{296FC0CD-BD61-D0D7-46F7-CB11855457A7}"/>
+                <a16:creationId xmlns:a16="http://schemas.microsoft.com/office/drawing/2014/main" id="{0B8A4828-1EFB-FDBA-CD93-314254C20BEB}"/>
               </a:ext>
             </a:extLst>
           </p:cNvPr>
@@ -11846,7 +11846,7 @@
           <p:cNvPr id="21" name="矩形 20">
             <a:extLst>
               <a:ext uri="{FF2B5EF4-FFF2-40B4-BE49-F238E27FC236}">
-                <a16:creationId xmlns:a16="http://schemas.microsoft.com/office/drawing/2014/main" id="{1EA199D7-FDE6-447C-6FED-5C7686307BCE}"/>
+                <a16:creationId xmlns:a16="http://schemas.microsoft.com/office/drawing/2014/main" id="{05CF6C67-CE0A-544A-11E0-D849FD7FCB64}"/>
               </a:ext>
             </a:extLst>
           </p:cNvPr>
@@ -11914,7 +11914,7 @@
           <p:cNvPr id="22" name="文本框 21">
             <a:extLst>
               <a:ext uri="{FF2B5EF4-FFF2-40B4-BE49-F238E27FC236}">
-                <a16:creationId xmlns:a16="http://schemas.microsoft.com/office/drawing/2014/main" id="{C85F21FB-E9E6-B697-337D-F9B6DA810AB9}"/>
+                <a16:creationId xmlns:a16="http://schemas.microsoft.com/office/drawing/2014/main" id="{677EF0A9-DFD3-7AA3-D7DF-EB71BAD8D362}"/>
               </a:ext>
             </a:extLst>
           </p:cNvPr>
@@ -11962,7 +11962,7 @@
           <p:cNvPr id="23" name="文本框 22">
             <a:extLst>
               <a:ext uri="{FF2B5EF4-FFF2-40B4-BE49-F238E27FC236}">
-                <a16:creationId xmlns:a16="http://schemas.microsoft.com/office/drawing/2014/main" id="{EA1DDBE8-851D-B821-8AF3-7E2A6396D5FE}"/>
+                <a16:creationId xmlns:a16="http://schemas.microsoft.com/office/drawing/2014/main" id="{C67865B0-37B7-BF38-7491-75F584309545}"/>
               </a:ext>
             </a:extLst>
           </p:cNvPr>
@@ -12010,7 +12010,7 @@
           <p:cNvPr id="24" name="矩形 23">
             <a:extLst>
               <a:ext uri="{FF2B5EF4-FFF2-40B4-BE49-F238E27FC236}">
-                <a16:creationId xmlns:a16="http://schemas.microsoft.com/office/drawing/2014/main" id="{CA67E8CC-F896-4BE5-62A6-B23EFA204AC3}"/>
+                <a16:creationId xmlns:a16="http://schemas.microsoft.com/office/drawing/2014/main" id="{AA9B127A-0D06-F828-FC60-1CF6AF1A050A}"/>
               </a:ext>
             </a:extLst>
           </p:cNvPr>
@@ -12078,7 +12078,7 @@
           <p:cNvPr id="25" name="矩形 24">
             <a:extLst>
               <a:ext uri="{FF2B5EF4-FFF2-40B4-BE49-F238E27FC236}">
-                <a16:creationId xmlns:a16="http://schemas.microsoft.com/office/drawing/2014/main" id="{917CAA77-B258-C105-F862-A049F627C90D}"/>
+                <a16:creationId xmlns:a16="http://schemas.microsoft.com/office/drawing/2014/main" id="{86B7F207-2215-B1EA-5741-802CDC5BF039}"/>
               </a:ext>
             </a:extLst>
           </p:cNvPr>
@@ -12146,7 +12146,7 @@
           <p:cNvPr id="26" name="文本框 25">
             <a:extLst>
               <a:ext uri="{FF2B5EF4-FFF2-40B4-BE49-F238E27FC236}">
-                <a16:creationId xmlns:a16="http://schemas.microsoft.com/office/drawing/2014/main" id="{C9D9C108-2445-78E9-A4F3-09702554D236}"/>
+                <a16:creationId xmlns:a16="http://schemas.microsoft.com/office/drawing/2014/main" id="{C8739B23-346C-F839-CD51-85BE102FBF19}"/>
               </a:ext>
             </a:extLst>
           </p:cNvPr>
@@ -12194,7 +12194,7 @@
           <p:cNvPr id="27" name="文本框 26">
             <a:extLst>
               <a:ext uri="{FF2B5EF4-FFF2-40B4-BE49-F238E27FC236}">
-                <a16:creationId xmlns:a16="http://schemas.microsoft.com/office/drawing/2014/main" id="{83969A06-F329-662C-1CBE-CD4F348C5332}"/>
+                <a16:creationId xmlns:a16="http://schemas.microsoft.com/office/drawing/2014/main" id="{EFA3FBF5-5CF3-3E18-6542-2DA7627D0F5F}"/>
               </a:ext>
             </a:extLst>
           </p:cNvPr>
@@ -12242,7 +12242,7 @@
           <p:cNvPr id="28" name="矩形 27">
             <a:extLst>
               <a:ext uri="{FF2B5EF4-FFF2-40B4-BE49-F238E27FC236}">
-                <a16:creationId xmlns:a16="http://schemas.microsoft.com/office/drawing/2014/main" id="{1F4C7CA9-7389-5B34-37FB-30AA7EA27347}"/>
+                <a16:creationId xmlns:a16="http://schemas.microsoft.com/office/drawing/2014/main" id="{B5A12260-54E6-2C8C-70E6-5D233B498130}"/>
               </a:ext>
             </a:extLst>
           </p:cNvPr>
@@ -12310,7 +12310,7 @@
           <p:cNvPr id="29" name="矩形 28">
             <a:extLst>
               <a:ext uri="{FF2B5EF4-FFF2-40B4-BE49-F238E27FC236}">
-                <a16:creationId xmlns:a16="http://schemas.microsoft.com/office/drawing/2014/main" id="{71D4D7F9-95B4-AF66-5D96-A3661478896B}"/>
+                <a16:creationId xmlns:a16="http://schemas.microsoft.com/office/drawing/2014/main" id="{7A8FE034-2EF1-9C0D-08E2-EF990B431ED1}"/>
               </a:ext>
             </a:extLst>
           </p:cNvPr>
@@ -12378,7 +12378,7 @@
           <p:cNvPr id="30" name="文本框 29">
             <a:extLst>
               <a:ext uri="{FF2B5EF4-FFF2-40B4-BE49-F238E27FC236}">
-                <a16:creationId xmlns:a16="http://schemas.microsoft.com/office/drawing/2014/main" id="{FB825533-D7B2-4A6E-EB5E-96846577BE7A}"/>
+                <a16:creationId xmlns:a16="http://schemas.microsoft.com/office/drawing/2014/main" id="{40D5AF94-33BE-9F56-307B-7CFFC291175A}"/>
               </a:ext>
             </a:extLst>
           </p:cNvPr>
@@ -12426,7 +12426,7 @@
           <p:cNvPr id="31" name="文本框 30">
             <a:extLst>
               <a:ext uri="{FF2B5EF4-FFF2-40B4-BE49-F238E27FC236}">
-                <a16:creationId xmlns:a16="http://schemas.microsoft.com/office/drawing/2014/main" id="{21A5F60F-328C-5CCF-F9BE-00D7B9D7E9CC}"/>
+                <a16:creationId xmlns:a16="http://schemas.microsoft.com/office/drawing/2014/main" id="{24C8D00F-1C00-B16A-448B-69120EA0A034}"/>
               </a:ext>
             </a:extLst>
           </p:cNvPr>
@@ -12474,7 +12474,7 @@
           <p:cNvPr id="32" name="矩形 31">
             <a:extLst>
               <a:ext uri="{FF2B5EF4-FFF2-40B4-BE49-F238E27FC236}">
-                <a16:creationId xmlns:a16="http://schemas.microsoft.com/office/drawing/2014/main" id="{2F39B9E3-55A6-0B53-EA35-23C9D2687A5A}"/>
+                <a16:creationId xmlns:a16="http://schemas.microsoft.com/office/drawing/2014/main" id="{7C4954B2-79F5-02C5-E423-B95FA7F45A3E}"/>
               </a:ext>
             </a:extLst>
           </p:cNvPr>
@@ -12542,7 +12542,7 @@
           <p:cNvPr id="33" name="矩形 32">
             <a:extLst>
               <a:ext uri="{FF2B5EF4-FFF2-40B4-BE49-F238E27FC236}">
-                <a16:creationId xmlns:a16="http://schemas.microsoft.com/office/drawing/2014/main" id="{4C351A9E-0DE0-47F6-9F59-6B3E1606F37A}"/>
+                <a16:creationId xmlns:a16="http://schemas.microsoft.com/office/drawing/2014/main" id="{CA731EA0-427A-28B4-6B80-0E0E0DEA6B77}"/>
               </a:ext>
             </a:extLst>
           </p:cNvPr>
@@ -12610,7 +12610,7 @@
           <p:cNvPr id="34" name="文本框 33">
             <a:extLst>
               <a:ext uri="{FF2B5EF4-FFF2-40B4-BE49-F238E27FC236}">
-                <a16:creationId xmlns:a16="http://schemas.microsoft.com/office/drawing/2014/main" id="{554F52A6-8DDA-E09F-1253-BD9204E9E9C8}"/>
+                <a16:creationId xmlns:a16="http://schemas.microsoft.com/office/drawing/2014/main" id="{8610BCE0-B543-63ED-EBAD-39F705354D21}"/>
               </a:ext>
             </a:extLst>
           </p:cNvPr>
@@ -12658,7 +12658,7 @@
           <p:cNvPr id="35" name="文本框 34">
             <a:extLst>
               <a:ext uri="{FF2B5EF4-FFF2-40B4-BE49-F238E27FC236}">
-                <a16:creationId xmlns:a16="http://schemas.microsoft.com/office/drawing/2014/main" id="{D3F85291-E3A2-C48D-3AC5-AAE1CDFC397C}"/>
+                <a16:creationId xmlns:a16="http://schemas.microsoft.com/office/drawing/2014/main" id="{CBA75DC0-6BAD-FE95-6327-436274EA52C8}"/>
               </a:ext>
             </a:extLst>
           </p:cNvPr>
@@ -12706,7 +12706,7 @@
           <p:cNvPr id="36" name="矩形 35">
             <a:extLst>
               <a:ext uri="{FF2B5EF4-FFF2-40B4-BE49-F238E27FC236}">
-                <a16:creationId xmlns:a16="http://schemas.microsoft.com/office/drawing/2014/main" id="{0BFDFC32-8462-A561-0885-10BBCDF730CC}"/>
+                <a16:creationId xmlns:a16="http://schemas.microsoft.com/office/drawing/2014/main" id="{669E8EF6-4A94-D73C-B3A5-755E9C953A66}"/>
               </a:ext>
             </a:extLst>
           </p:cNvPr>
@@ -12774,7 +12774,7 @@
           <p:cNvPr id="37" name="矩形 36">
             <a:extLst>
               <a:ext uri="{FF2B5EF4-FFF2-40B4-BE49-F238E27FC236}">
-                <a16:creationId xmlns:a16="http://schemas.microsoft.com/office/drawing/2014/main" id="{7ED1C5FE-0BE4-E599-0125-B342637E2C22}"/>
+                <a16:creationId xmlns:a16="http://schemas.microsoft.com/office/drawing/2014/main" id="{B2904F61-E774-C87F-85DE-39F7B7C5C759}"/>
               </a:ext>
             </a:extLst>
           </p:cNvPr>
@@ -12842,7 +12842,7 @@
           <p:cNvPr id="38" name="文本框 37">
             <a:extLst>
               <a:ext uri="{FF2B5EF4-FFF2-40B4-BE49-F238E27FC236}">
-                <a16:creationId xmlns:a16="http://schemas.microsoft.com/office/drawing/2014/main" id="{6EBF2AD6-F4B9-3547-AC45-12941E8F4423}"/>
+                <a16:creationId xmlns:a16="http://schemas.microsoft.com/office/drawing/2014/main" id="{AD43A12B-96EB-7FE6-1F58-160F5832A41E}"/>
               </a:ext>
             </a:extLst>
           </p:cNvPr>
@@ -12890,7 +12890,7 @@
           <p:cNvPr id="39" name="文本框 38">
             <a:extLst>
               <a:ext uri="{FF2B5EF4-FFF2-40B4-BE49-F238E27FC236}">
-                <a16:creationId xmlns:a16="http://schemas.microsoft.com/office/drawing/2014/main" id="{539C7207-74FD-D18B-7964-FB97F5BB6901}"/>
+                <a16:creationId xmlns:a16="http://schemas.microsoft.com/office/drawing/2014/main" id="{B90C5CEF-36F8-407E-FDAE-FDDB110C4403}"/>
               </a:ext>
             </a:extLst>
           </p:cNvPr>
@@ -12938,7 +12938,7 @@
           <p:cNvPr id="40" name="矩形 39">
             <a:extLst>
               <a:ext uri="{FF2B5EF4-FFF2-40B4-BE49-F238E27FC236}">
-                <a16:creationId xmlns:a16="http://schemas.microsoft.com/office/drawing/2014/main" id="{65A97584-3CB7-1796-53AA-67F529A917C3}"/>
+                <a16:creationId xmlns:a16="http://schemas.microsoft.com/office/drawing/2014/main" id="{66276A1E-234E-C37A-985A-B08ECEA42168}"/>
               </a:ext>
             </a:extLst>
           </p:cNvPr>
@@ -13006,7 +13006,7 @@
           <p:cNvPr id="41" name="矩形 40">
             <a:extLst>
               <a:ext uri="{FF2B5EF4-FFF2-40B4-BE49-F238E27FC236}">
-                <a16:creationId xmlns:a16="http://schemas.microsoft.com/office/drawing/2014/main" id="{5C3252FF-552C-5DE2-06A9-92A4053F23CD}"/>
+                <a16:creationId xmlns:a16="http://schemas.microsoft.com/office/drawing/2014/main" id="{22C081C7-2592-8D19-C209-92E0C490E46A}"/>
               </a:ext>
             </a:extLst>
           </p:cNvPr>
@@ -13074,7 +13074,7 @@
           <p:cNvPr id="42" name="文本框 41">
             <a:extLst>
               <a:ext uri="{FF2B5EF4-FFF2-40B4-BE49-F238E27FC236}">
-                <a16:creationId xmlns:a16="http://schemas.microsoft.com/office/drawing/2014/main" id="{61B8690B-0558-859E-1049-C5049D55F7C3}"/>
+                <a16:creationId xmlns:a16="http://schemas.microsoft.com/office/drawing/2014/main" id="{1282729C-25C1-E0B0-E4F1-3231D80B69D8}"/>
               </a:ext>
             </a:extLst>
           </p:cNvPr>
@@ -13122,7 +13122,7 @@
           <p:cNvPr id="43" name="文本框 42">
             <a:extLst>
               <a:ext uri="{FF2B5EF4-FFF2-40B4-BE49-F238E27FC236}">
-                <a16:creationId xmlns:a16="http://schemas.microsoft.com/office/drawing/2014/main" id="{9AE4DC85-F1FD-52C0-D209-56E186EC44CF}"/>
+                <a16:creationId xmlns:a16="http://schemas.microsoft.com/office/drawing/2014/main" id="{4A62D8D7-9C5D-BBA2-48AB-36AB8AC9CAB1}"/>
               </a:ext>
             </a:extLst>
           </p:cNvPr>
@@ -13170,7 +13170,7 @@
           <p:cNvPr id="44" name="矩形 43">
             <a:extLst>
               <a:ext uri="{FF2B5EF4-FFF2-40B4-BE49-F238E27FC236}">
-                <a16:creationId xmlns:a16="http://schemas.microsoft.com/office/drawing/2014/main" id="{7046A3D9-07BB-A87C-CC70-83D649650A82}"/>
+                <a16:creationId xmlns:a16="http://schemas.microsoft.com/office/drawing/2014/main" id="{07556F91-545A-1F3F-E980-0463B120C836}"/>
               </a:ext>
             </a:extLst>
           </p:cNvPr>
@@ -13238,7 +13238,7 @@
           <p:cNvPr id="45" name="矩形 44">
             <a:extLst>
               <a:ext uri="{FF2B5EF4-FFF2-40B4-BE49-F238E27FC236}">
-                <a16:creationId xmlns:a16="http://schemas.microsoft.com/office/drawing/2014/main" id="{3D0E1063-9FFE-360A-0022-07D3A333CFC6}"/>
+                <a16:creationId xmlns:a16="http://schemas.microsoft.com/office/drawing/2014/main" id="{C947DA5D-344F-CB7F-00B4-B505D80C81FB}"/>
               </a:ext>
             </a:extLst>
           </p:cNvPr>
@@ -13306,7 +13306,7 @@
           <p:cNvPr id="46" name="文本框 45">
             <a:extLst>
               <a:ext uri="{FF2B5EF4-FFF2-40B4-BE49-F238E27FC236}">
-                <a16:creationId xmlns:a16="http://schemas.microsoft.com/office/drawing/2014/main" id="{1975E9DB-F99A-728B-3DA7-7A86DBD84917}"/>
+                <a16:creationId xmlns:a16="http://schemas.microsoft.com/office/drawing/2014/main" id="{94648AB1-B66D-D315-D9F4-47312033E312}"/>
               </a:ext>
             </a:extLst>
           </p:cNvPr>
@@ -13354,7 +13354,7 @@
           <p:cNvPr id="47" name="文本框 46">
             <a:extLst>
               <a:ext uri="{FF2B5EF4-FFF2-40B4-BE49-F238E27FC236}">
-                <a16:creationId xmlns:a16="http://schemas.microsoft.com/office/drawing/2014/main" id="{DF969D85-79F7-0DA1-BF94-520140104070}"/>
+                <a16:creationId xmlns:a16="http://schemas.microsoft.com/office/drawing/2014/main" id="{7889F798-482D-FFC7-98A3-E4FECE8DB216}"/>
               </a:ext>
             </a:extLst>
           </p:cNvPr>
@@ -13402,7 +13402,7 @@
           <p:cNvPr id="48" name="矩形 47">
             <a:extLst>
               <a:ext uri="{FF2B5EF4-FFF2-40B4-BE49-F238E27FC236}">
-                <a16:creationId xmlns:a16="http://schemas.microsoft.com/office/drawing/2014/main" id="{DEF09ECD-0A40-4615-FF9B-158E3F517D00}"/>
+                <a16:creationId xmlns:a16="http://schemas.microsoft.com/office/drawing/2014/main" id="{7FE6D789-7714-8412-1971-629C44760C6A}"/>
               </a:ext>
             </a:extLst>
           </p:cNvPr>
@@ -13470,7 +13470,7 @@
           <p:cNvPr id="49" name="矩形 48">
             <a:extLst>
               <a:ext uri="{FF2B5EF4-FFF2-40B4-BE49-F238E27FC236}">
-                <a16:creationId xmlns:a16="http://schemas.microsoft.com/office/drawing/2014/main" id="{044113B5-1210-7A37-1263-1EAE99AE3E5C}"/>
+                <a16:creationId xmlns:a16="http://schemas.microsoft.com/office/drawing/2014/main" id="{FA250BEF-CD02-AC9C-DE69-C55697FF2FE9}"/>
               </a:ext>
             </a:extLst>
           </p:cNvPr>
@@ -13538,7 +13538,7 @@
           <p:cNvPr id="50" name="文本框 49">
             <a:extLst>
               <a:ext uri="{FF2B5EF4-FFF2-40B4-BE49-F238E27FC236}">
-                <a16:creationId xmlns:a16="http://schemas.microsoft.com/office/drawing/2014/main" id="{EEB7BD78-8678-5701-014F-A878141A3497}"/>
+                <a16:creationId xmlns:a16="http://schemas.microsoft.com/office/drawing/2014/main" id="{5DDFDA0D-BC67-621C-03F5-4273BA1DCC02}"/>
               </a:ext>
             </a:extLst>
           </p:cNvPr>
@@ -13586,7 +13586,7 @@
           <p:cNvPr id="51" name="文本框 50">
             <a:extLst>
               <a:ext uri="{FF2B5EF4-FFF2-40B4-BE49-F238E27FC236}">
-                <a16:creationId xmlns:a16="http://schemas.microsoft.com/office/drawing/2014/main" id="{87571A3B-03E8-241B-5D50-01CE52EE8303}"/>
+                <a16:creationId xmlns:a16="http://schemas.microsoft.com/office/drawing/2014/main" id="{530B5703-10DF-1A30-D3EA-5CCF0991A94F}"/>
               </a:ext>
             </a:extLst>
           </p:cNvPr>
@@ -13684,7 +13684,7 @@
           <p:cNvPr id="52" name="文本框 51">
             <a:extLst>
               <a:ext uri="{FF2B5EF4-FFF2-40B4-BE49-F238E27FC236}">
-                <a16:creationId xmlns:a16="http://schemas.microsoft.com/office/drawing/2014/main" id="{F70B4BD4-E62A-2ABA-7668-AFEAC174149F}"/>
+                <a16:creationId xmlns:a16="http://schemas.microsoft.com/office/drawing/2014/main" id="{F07F48DF-ECCE-E2DA-467F-27CA3BAA63C8}"/>
               </a:ext>
             </a:extLst>
           </p:cNvPr>
@@ -13782,7 +13782,7 @@
           <p:cNvPr id="53" name="文本框 52">
             <a:extLst>
               <a:ext uri="{FF2B5EF4-FFF2-40B4-BE49-F238E27FC236}">
-                <a16:creationId xmlns:a16="http://schemas.microsoft.com/office/drawing/2014/main" id="{DDEE57F1-6679-9DDB-F9B0-FE37953D9F81}"/>
+                <a16:creationId xmlns:a16="http://schemas.microsoft.com/office/drawing/2014/main" id="{5C40E31D-29A7-FCBD-639D-46CFE8FD4A24}"/>
               </a:ext>
             </a:extLst>
           </p:cNvPr>
@@ -13833,7 +13833,7 @@
           <p:cNvPr id="54" name="矩形 53">
             <a:extLst>
               <a:ext uri="{FF2B5EF4-FFF2-40B4-BE49-F238E27FC236}">
-                <a16:creationId xmlns:a16="http://schemas.microsoft.com/office/drawing/2014/main" id="{7CE09AB5-8F64-0DC9-C71F-5E6BDD2F3FA7}"/>
+                <a16:creationId xmlns:a16="http://schemas.microsoft.com/office/drawing/2014/main" id="{ED23DFD9-0A36-A03F-7A4B-D7561644AA9F}"/>
               </a:ext>
             </a:extLst>
           </p:cNvPr>
@@ -13901,7 +13901,7 @@
           <p:cNvPr id="55" name="文本框 54">
             <a:extLst>
               <a:ext uri="{FF2B5EF4-FFF2-40B4-BE49-F238E27FC236}">
-                <a16:creationId xmlns:a16="http://schemas.microsoft.com/office/drawing/2014/main" id="{0F7EEF5E-22B0-359B-8877-FAB8AD135C39}"/>
+                <a16:creationId xmlns:a16="http://schemas.microsoft.com/office/drawing/2014/main" id="{C7CDCCFE-35DC-4BF1-5526-E1D81E22D871}"/>
               </a:ext>
             </a:extLst>
           </p:cNvPr>
@@ -13942,7 +13942,7 @@
           <p:cNvPr id="56" name="直接连接符 55">
             <a:extLst>
               <a:ext uri="{FF2B5EF4-FFF2-40B4-BE49-F238E27FC236}">
-                <a16:creationId xmlns:a16="http://schemas.microsoft.com/office/drawing/2014/main" id="{11D3F764-805A-0831-B5F7-1F694D821437}"/>
+                <a16:creationId xmlns:a16="http://schemas.microsoft.com/office/drawing/2014/main" id="{533AA44D-2C3C-620E-FF54-9525B88BB69B}"/>
               </a:ext>
             </a:extLst>
           </p:cNvPr>
@@ -13984,7 +13984,7 @@
             <a:hlinkClick r:id="rId3"/>
             <a:extLst>
               <a:ext uri="{FF2B5EF4-FFF2-40B4-BE49-F238E27FC236}">
-                <a16:creationId xmlns:a16="http://schemas.microsoft.com/office/drawing/2014/main" id="{D12EE5E1-4EB0-3EB8-09F0-290F08868C2C}"/>
+                <a16:creationId xmlns:a16="http://schemas.microsoft.com/office/drawing/2014/main" id="{2C35F2C8-DAD6-DC5C-074C-903BFD23099E}"/>
               </a:ext>
             </a:extLst>
           </p:cNvPr>
@@ -14103,7 +14103,7 @@
     </p:spTree>
     <p:extLst>
       <p:ext uri="{BB962C8B-B14F-4D97-AF65-F5344CB8AC3E}">
-        <p14:creationId xmlns:p14="http://schemas.microsoft.com/office/powerpoint/2010/main" val="4192036399"/>
+        <p14:creationId xmlns:p14="http://schemas.microsoft.com/office/powerpoint/2010/main" val="2698720717"/>
       </p:ext>
     </p:extLst>
   </p:cSld>
@@ -14143,7 +14143,7 @@
           <p:cNvPr id="2" name="矩形 1">
             <a:extLst>
               <a:ext uri="{FF2B5EF4-FFF2-40B4-BE49-F238E27FC236}">
-                <a16:creationId xmlns:a16="http://schemas.microsoft.com/office/drawing/2014/main" id="{3A9BC1D4-0890-C00E-1DD3-3B57F21E46F1}"/>
+                <a16:creationId xmlns:a16="http://schemas.microsoft.com/office/drawing/2014/main" id="{7FFD47B7-F8CD-B02D-1688-C3065240D9AA}"/>
               </a:ext>
             </a:extLst>
           </p:cNvPr>
@@ -14211,7 +14211,7 @@
           <p:cNvPr id="3" name="文本框 2">
             <a:extLst>
               <a:ext uri="{FF2B5EF4-FFF2-40B4-BE49-F238E27FC236}">
-                <a16:creationId xmlns:a16="http://schemas.microsoft.com/office/drawing/2014/main" id="{BA024582-B39A-B82A-606E-AAB6D8DEF765}"/>
+                <a16:creationId xmlns:a16="http://schemas.microsoft.com/office/drawing/2014/main" id="{920F2D2D-9D2C-1C55-E8A9-D72ECF5D5632}"/>
               </a:ext>
             </a:extLst>
           </p:cNvPr>
@@ -14259,7 +14259,7 @@
           <p:cNvPr id="4" name="文本框 3">
             <a:extLst>
               <a:ext uri="{FF2B5EF4-FFF2-40B4-BE49-F238E27FC236}">
-                <a16:creationId xmlns:a16="http://schemas.microsoft.com/office/drawing/2014/main" id="{5CBD6E69-A53C-BE59-D7C6-D1831A50CD4F}"/>
+                <a16:creationId xmlns:a16="http://schemas.microsoft.com/office/drawing/2014/main" id="{8CBFB80F-7357-03E4-497B-EAE7787F37A2}"/>
               </a:ext>
             </a:extLst>
           </p:cNvPr>
@@ -14311,7 +14311,7 @@
           <p:cNvPr id="5" name="文本框 4">
             <a:extLst>
               <a:ext uri="{FF2B5EF4-FFF2-40B4-BE49-F238E27FC236}">
-                <a16:creationId xmlns:a16="http://schemas.microsoft.com/office/drawing/2014/main" id="{B4F1525A-4105-6D66-9F43-998E2317EE8D}"/>
+                <a16:creationId xmlns:a16="http://schemas.microsoft.com/office/drawing/2014/main" id="{E5207E25-A4A8-F045-D9B7-23E4674B84BB}"/>
               </a:ext>
             </a:extLst>
           </p:cNvPr>
@@ -14369,7 +14369,7 @@
           <p:cNvPr id="6" name="文本框 5">
             <a:extLst>
               <a:ext uri="{FF2B5EF4-FFF2-40B4-BE49-F238E27FC236}">
-                <a16:creationId xmlns:a16="http://schemas.microsoft.com/office/drawing/2014/main" id="{AADF395D-14EB-2A48-03FC-9CBC14F5BD4A}"/>
+                <a16:creationId xmlns:a16="http://schemas.microsoft.com/office/drawing/2014/main" id="{C6029C6B-9A2A-F164-94A8-5003FB83FA0A}"/>
               </a:ext>
             </a:extLst>
           </p:cNvPr>
@@ -14450,7 +14450,7 @@
           <p:cNvPr id="7" name="文本框 6">
             <a:extLst>
               <a:ext uri="{FF2B5EF4-FFF2-40B4-BE49-F238E27FC236}">
-                <a16:creationId xmlns:a16="http://schemas.microsoft.com/office/drawing/2014/main" id="{B27DBBF2-3DCD-2245-955F-3D73AD99B91B}"/>
+                <a16:creationId xmlns:a16="http://schemas.microsoft.com/office/drawing/2014/main" id="{54905F1B-4E32-A64E-B0E4-5C9F9BED2A8D}"/>
               </a:ext>
             </a:extLst>
           </p:cNvPr>
@@ -14499,7 +14499,7 @@
           <p:cNvPr id="8" name="矩形 7">
             <a:extLst>
               <a:ext uri="{FF2B5EF4-FFF2-40B4-BE49-F238E27FC236}">
-                <a16:creationId xmlns:a16="http://schemas.microsoft.com/office/drawing/2014/main" id="{F59BD75B-6E98-B2BD-1EE0-E7158A16DD66}"/>
+                <a16:creationId xmlns:a16="http://schemas.microsoft.com/office/drawing/2014/main" id="{9CBC5C40-C060-93A5-1D58-6D05188FAEEC}"/>
               </a:ext>
             </a:extLst>
           </p:cNvPr>
@@ -14553,7 +14553,7 @@
           <p:cNvPr id="9" name="文本框 8">
             <a:extLst>
               <a:ext uri="{FF2B5EF4-FFF2-40B4-BE49-F238E27FC236}">
-                <a16:creationId xmlns:a16="http://schemas.microsoft.com/office/drawing/2014/main" id="{B8B45AEC-33E7-6D99-EAF8-AD360993F6D1}"/>
+                <a16:creationId xmlns:a16="http://schemas.microsoft.com/office/drawing/2014/main" id="{6C47F8E5-D393-B994-1FDC-A724BB4D3431}"/>
               </a:ext>
             </a:extLst>
           </p:cNvPr>
@@ -14604,7 +14604,7 @@
           <p:cNvPr id="10" name="文本框 9">
             <a:extLst>
               <a:ext uri="{FF2B5EF4-FFF2-40B4-BE49-F238E27FC236}">
-                <a16:creationId xmlns:a16="http://schemas.microsoft.com/office/drawing/2014/main" id="{040DB6FD-D2C2-859B-1317-0A8C11862D46}"/>
+                <a16:creationId xmlns:a16="http://schemas.microsoft.com/office/drawing/2014/main" id="{57420042-E38D-D95B-8F04-2FEEF4EF9650}"/>
               </a:ext>
             </a:extLst>
           </p:cNvPr>
@@ -14645,7 +14645,7 @@
           <p:cNvPr id="11" name="文本框 10">
             <a:extLst>
               <a:ext uri="{FF2B5EF4-FFF2-40B4-BE49-F238E27FC236}">
-                <a16:creationId xmlns:a16="http://schemas.microsoft.com/office/drawing/2014/main" id="{52E4771A-C3E4-9BF7-1096-7C756CE6E9BF}"/>
+                <a16:creationId xmlns:a16="http://schemas.microsoft.com/office/drawing/2014/main" id="{03D2557E-90C3-D52C-2183-B8F23AC5375B}"/>
               </a:ext>
             </a:extLst>
           </p:cNvPr>
@@ -14694,7 +14694,7 @@
           <p:cNvPr id="12" name="直接连接符 11">
             <a:extLst>
               <a:ext uri="{FF2B5EF4-FFF2-40B4-BE49-F238E27FC236}">
-                <a16:creationId xmlns:a16="http://schemas.microsoft.com/office/drawing/2014/main" id="{4B2F6FCB-AF89-B694-037A-D14C8D301301}"/>
+                <a16:creationId xmlns:a16="http://schemas.microsoft.com/office/drawing/2014/main" id="{1C2BA81F-323C-BF1C-498B-94744192B771}"/>
               </a:ext>
             </a:extLst>
           </p:cNvPr>
@@ -14736,7 +14736,7 @@
           <p:cNvPr id="13" name="矩形 12">
             <a:extLst>
               <a:ext uri="{FF2B5EF4-FFF2-40B4-BE49-F238E27FC236}">
-                <a16:creationId xmlns:a16="http://schemas.microsoft.com/office/drawing/2014/main" id="{A3BDAD2D-2E4B-8193-BD0E-23A4A337BE1D}"/>
+                <a16:creationId xmlns:a16="http://schemas.microsoft.com/office/drawing/2014/main" id="{D6545184-C068-8271-1885-AF3A9E077F82}"/>
               </a:ext>
             </a:extLst>
           </p:cNvPr>
@@ -14790,7 +14790,7 @@
           <p:cNvPr id="14" name="文本框 13">
             <a:extLst>
               <a:ext uri="{FF2B5EF4-FFF2-40B4-BE49-F238E27FC236}">
-                <a16:creationId xmlns:a16="http://schemas.microsoft.com/office/drawing/2014/main" id="{7EA287ED-9C38-C9E7-CF00-175258D159BB}"/>
+                <a16:creationId xmlns:a16="http://schemas.microsoft.com/office/drawing/2014/main" id="{2310FA01-1E71-BB8C-D48A-174E01A9BDF3}"/>
               </a:ext>
             </a:extLst>
           </p:cNvPr>
@@ -14831,7 +14831,7 @@
           <p:cNvPr id="15" name="文本框 14">
             <a:extLst>
               <a:ext uri="{FF2B5EF4-FFF2-40B4-BE49-F238E27FC236}">
-                <a16:creationId xmlns:a16="http://schemas.microsoft.com/office/drawing/2014/main" id="{FE02211C-7306-32FB-B757-A0B8A322FC92}"/>
+                <a16:creationId xmlns:a16="http://schemas.microsoft.com/office/drawing/2014/main" id="{E7BBEA34-12FA-12D6-F0F5-A167ED1D885E}"/>
               </a:ext>
             </a:extLst>
           </p:cNvPr>
@@ -14872,7 +14872,7 @@
           <p:cNvPr id="16" name="文本框 15">
             <a:extLst>
               <a:ext uri="{FF2B5EF4-FFF2-40B4-BE49-F238E27FC236}">
-                <a16:creationId xmlns:a16="http://schemas.microsoft.com/office/drawing/2014/main" id="{FE1F7B81-64C9-F04F-1166-C958717FDDC4}"/>
+                <a16:creationId xmlns:a16="http://schemas.microsoft.com/office/drawing/2014/main" id="{238FA421-7B50-6EBC-0385-CD50A5AF21AD}"/>
               </a:ext>
             </a:extLst>
           </p:cNvPr>
@@ -14921,7 +14921,7 @@
           <p:cNvPr id="17" name="直接连接符 16">
             <a:extLst>
               <a:ext uri="{FF2B5EF4-FFF2-40B4-BE49-F238E27FC236}">
-                <a16:creationId xmlns:a16="http://schemas.microsoft.com/office/drawing/2014/main" id="{27A995A9-C8CA-0CFD-26A0-AB709D445AE5}"/>
+                <a16:creationId xmlns:a16="http://schemas.microsoft.com/office/drawing/2014/main" id="{297B718F-AF28-F635-EB3C-84F04BDA46EF}"/>
               </a:ext>
             </a:extLst>
           </p:cNvPr>
@@ -14963,7 +14963,7 @@
           <p:cNvPr id="18" name="矩形 17">
             <a:extLst>
               <a:ext uri="{FF2B5EF4-FFF2-40B4-BE49-F238E27FC236}">
-                <a16:creationId xmlns:a16="http://schemas.microsoft.com/office/drawing/2014/main" id="{2E8A1F3F-449D-8DB0-1C1D-39DFA2A65298}"/>
+                <a16:creationId xmlns:a16="http://schemas.microsoft.com/office/drawing/2014/main" id="{66FAEE36-7E10-D99C-1818-6A7D7E9FE098}"/>
               </a:ext>
             </a:extLst>
           </p:cNvPr>
@@ -15017,7 +15017,7 @@
           <p:cNvPr id="19" name="文本框 18">
             <a:extLst>
               <a:ext uri="{FF2B5EF4-FFF2-40B4-BE49-F238E27FC236}">
-                <a16:creationId xmlns:a16="http://schemas.microsoft.com/office/drawing/2014/main" id="{72B6D632-60E1-8CCB-59B4-93381FA7B1A1}"/>
+                <a16:creationId xmlns:a16="http://schemas.microsoft.com/office/drawing/2014/main" id="{2A8F6EF7-B57A-F039-1CB3-067884B75807}"/>
               </a:ext>
             </a:extLst>
           </p:cNvPr>
@@ -15068,7 +15068,7 @@
           <p:cNvPr id="20" name="文本框 19">
             <a:extLst>
               <a:ext uri="{FF2B5EF4-FFF2-40B4-BE49-F238E27FC236}">
-                <a16:creationId xmlns:a16="http://schemas.microsoft.com/office/drawing/2014/main" id="{9C23EA0E-8E6A-C105-D2FE-16119E6743DD}"/>
+                <a16:creationId xmlns:a16="http://schemas.microsoft.com/office/drawing/2014/main" id="{8CF6CA37-9FAE-771D-6FDB-82877FA68B10}"/>
               </a:ext>
             </a:extLst>
           </p:cNvPr>
@@ -15109,7 +15109,7 @@
           <p:cNvPr id="21" name="文本框 20">
             <a:extLst>
               <a:ext uri="{FF2B5EF4-FFF2-40B4-BE49-F238E27FC236}">
-                <a16:creationId xmlns:a16="http://schemas.microsoft.com/office/drawing/2014/main" id="{0F7AFABD-655A-1F46-2D26-58AF62E17E16}"/>
+                <a16:creationId xmlns:a16="http://schemas.microsoft.com/office/drawing/2014/main" id="{11071445-C050-6554-0969-D7AEEE8FB6A8}"/>
               </a:ext>
             </a:extLst>
           </p:cNvPr>
@@ -15161,7 +15161,7 @@
           <p:cNvPr id="22" name="直接连接符 21">
             <a:extLst>
               <a:ext uri="{FF2B5EF4-FFF2-40B4-BE49-F238E27FC236}">
-                <a16:creationId xmlns:a16="http://schemas.microsoft.com/office/drawing/2014/main" id="{0F015859-EDE0-D421-ECF0-34C74D5D6065}"/>
+                <a16:creationId xmlns:a16="http://schemas.microsoft.com/office/drawing/2014/main" id="{46573FE6-B047-9619-2417-97C34009079B}"/>
               </a:ext>
             </a:extLst>
           </p:cNvPr>
@@ -15202,7 +15202,7 @@
           <p:cNvPr id="23" name="文本框 22">
             <a:extLst>
               <a:ext uri="{FF2B5EF4-FFF2-40B4-BE49-F238E27FC236}">
-                <a16:creationId xmlns:a16="http://schemas.microsoft.com/office/drawing/2014/main" id="{D075D539-4E64-5212-0F29-F967EB93EAFE}"/>
+                <a16:creationId xmlns:a16="http://schemas.microsoft.com/office/drawing/2014/main" id="{FE322210-3EE9-D73A-00E0-83A952147A71}"/>
               </a:ext>
             </a:extLst>
           </p:cNvPr>
@@ -15243,7 +15243,7 @@
           <p:cNvPr id="24" name="文本框 23">
             <a:extLst>
               <a:ext uri="{FF2B5EF4-FFF2-40B4-BE49-F238E27FC236}">
-                <a16:creationId xmlns:a16="http://schemas.microsoft.com/office/drawing/2014/main" id="{243B9696-7746-15C1-5AD2-1A32215F1734}"/>
+                <a16:creationId xmlns:a16="http://schemas.microsoft.com/office/drawing/2014/main" id="{BB7A9B73-0E8C-DA25-924C-66D1CBE02D4E}"/>
               </a:ext>
             </a:extLst>
           </p:cNvPr>
@@ -15321,7 +15321,7 @@
           <p:cNvPr id="25" name="文本框 24">
             <a:extLst>
               <a:ext uri="{FF2B5EF4-FFF2-40B4-BE49-F238E27FC236}">
-                <a16:creationId xmlns:a16="http://schemas.microsoft.com/office/drawing/2014/main" id="{DF3C3A2D-E1DC-A276-FEEC-1894D37CCD7A}"/>
+                <a16:creationId xmlns:a16="http://schemas.microsoft.com/office/drawing/2014/main" id="{C6500A59-6764-85A4-9B45-19A906E43EAA}"/>
               </a:ext>
             </a:extLst>
           </p:cNvPr>
@@ -15372,7 +15372,7 @@
           <p:cNvPr id="26" name="文本框 25">
             <a:extLst>
               <a:ext uri="{FF2B5EF4-FFF2-40B4-BE49-F238E27FC236}">
-                <a16:creationId xmlns:a16="http://schemas.microsoft.com/office/drawing/2014/main" id="{6B8B0CE8-87B9-B4EA-9B18-EBE39C5240A2}"/>
+                <a16:creationId xmlns:a16="http://schemas.microsoft.com/office/drawing/2014/main" id="{2FE90B90-0532-CB2F-C121-936A4C2259CC}"/>
               </a:ext>
             </a:extLst>
           </p:cNvPr>
@@ -15434,7 +15434,7 @@
           <p:cNvPr id="27" name="矩形 26">
             <a:extLst>
               <a:ext uri="{FF2B5EF4-FFF2-40B4-BE49-F238E27FC236}">
-                <a16:creationId xmlns:a16="http://schemas.microsoft.com/office/drawing/2014/main" id="{CA07EF75-3F0B-9A15-5116-2FC77E9C27F1}"/>
+                <a16:creationId xmlns:a16="http://schemas.microsoft.com/office/drawing/2014/main" id="{51E7FB5B-55EE-C939-DEE0-57E0F7455C19}"/>
               </a:ext>
             </a:extLst>
           </p:cNvPr>
@@ -15502,7 +15502,7 @@
           <p:cNvPr id="28" name="文本框 27">
             <a:extLst>
               <a:ext uri="{FF2B5EF4-FFF2-40B4-BE49-F238E27FC236}">
-                <a16:creationId xmlns:a16="http://schemas.microsoft.com/office/drawing/2014/main" id="{BBEA3F63-4B2D-2996-AACC-7AF684AE9D87}"/>
+                <a16:creationId xmlns:a16="http://schemas.microsoft.com/office/drawing/2014/main" id="{FF4B3E98-AF18-ACD4-AB37-431381980BD5}"/>
               </a:ext>
             </a:extLst>
           </p:cNvPr>
@@ -15573,7 +15573,7 @@
           <p:cNvPr id="29" name="直接连接符 28">
             <a:extLst>
               <a:ext uri="{FF2B5EF4-FFF2-40B4-BE49-F238E27FC236}">
-                <a16:creationId xmlns:a16="http://schemas.microsoft.com/office/drawing/2014/main" id="{5C047880-59F2-C0AC-8745-D44B9A1150AF}"/>
+                <a16:creationId xmlns:a16="http://schemas.microsoft.com/office/drawing/2014/main" id="{DA4CA1F9-DD27-196E-C7FB-D318D19A5792}"/>
               </a:ext>
             </a:extLst>
           </p:cNvPr>
@@ -15615,7 +15615,7 @@
             <a:hlinkClick r:id="rId3"/>
             <a:extLst>
               <a:ext uri="{FF2B5EF4-FFF2-40B4-BE49-F238E27FC236}">
-                <a16:creationId xmlns:a16="http://schemas.microsoft.com/office/drawing/2014/main" id="{24AD50AD-B8F0-B321-711B-1C97B3D241C8}"/>
+                <a16:creationId xmlns:a16="http://schemas.microsoft.com/office/drawing/2014/main" id="{3A85C09E-2CBE-8225-4997-AC8B855BF15B}"/>
               </a:ext>
             </a:extLst>
           </p:cNvPr>
@@ -15704,7 +15704,7 @@
     </p:spTree>
     <p:extLst>
       <p:ext uri="{BB962C8B-B14F-4D97-AF65-F5344CB8AC3E}">
-        <p14:creationId xmlns:p14="http://schemas.microsoft.com/office/powerpoint/2010/main" val="2316445493"/>
+        <p14:creationId xmlns:p14="http://schemas.microsoft.com/office/powerpoint/2010/main" val="4254728063"/>
       </p:ext>
     </p:extLst>
   </p:cSld>
@@ -15744,7 +15744,7 @@
           <p:cNvPr id="2" name="矩形 1">
             <a:extLst>
               <a:ext uri="{FF2B5EF4-FFF2-40B4-BE49-F238E27FC236}">
-                <a16:creationId xmlns:a16="http://schemas.microsoft.com/office/drawing/2014/main" id="{2869AB62-2782-CA8B-1607-999F0927D3D3}"/>
+                <a16:creationId xmlns:a16="http://schemas.microsoft.com/office/drawing/2014/main" id="{BDF16068-C20A-479F-90E9-FAA89DCB73FE}"/>
               </a:ext>
             </a:extLst>
           </p:cNvPr>
@@ -15812,7 +15812,7 @@
           <p:cNvPr id="3" name="文本框 2">
             <a:extLst>
               <a:ext uri="{FF2B5EF4-FFF2-40B4-BE49-F238E27FC236}">
-                <a16:creationId xmlns:a16="http://schemas.microsoft.com/office/drawing/2014/main" id="{63D5C91F-660E-D23C-1658-859461C75B22}"/>
+                <a16:creationId xmlns:a16="http://schemas.microsoft.com/office/drawing/2014/main" id="{153CF52C-6C63-A6C0-2487-E2BC128A3BFB}"/>
               </a:ext>
             </a:extLst>
           </p:cNvPr>
@@ -15860,7 +15860,7 @@
           <p:cNvPr id="4" name="文本框 3">
             <a:extLst>
               <a:ext uri="{FF2B5EF4-FFF2-40B4-BE49-F238E27FC236}">
-                <a16:creationId xmlns:a16="http://schemas.microsoft.com/office/drawing/2014/main" id="{EA35B0E5-C4E1-67FD-825B-D90C03B4C9B8}"/>
+                <a16:creationId xmlns:a16="http://schemas.microsoft.com/office/drawing/2014/main" id="{968A4AF5-F5EF-3C9F-D406-EDBE170ED1BC}"/>
               </a:ext>
             </a:extLst>
           </p:cNvPr>
@@ -15912,7 +15912,7 @@
           <p:cNvPr id="5" name="文本框 4">
             <a:extLst>
               <a:ext uri="{FF2B5EF4-FFF2-40B4-BE49-F238E27FC236}">
-                <a16:creationId xmlns:a16="http://schemas.microsoft.com/office/drawing/2014/main" id="{D3E1AB8E-04AF-7826-2837-032EC57B8F46}"/>
+                <a16:creationId xmlns:a16="http://schemas.microsoft.com/office/drawing/2014/main" id="{D5A44523-5429-AC14-F652-F62F57C81907}"/>
               </a:ext>
             </a:extLst>
           </p:cNvPr>
@@ -15953,7 +15953,7 @@
           <p:cNvPr id="6" name="文本框 5">
             <a:extLst>
               <a:ext uri="{FF2B5EF4-FFF2-40B4-BE49-F238E27FC236}">
-                <a16:creationId xmlns:a16="http://schemas.microsoft.com/office/drawing/2014/main" id="{041DA779-088D-C0B3-5AC9-AE0DE9E795E7}"/>
+                <a16:creationId xmlns:a16="http://schemas.microsoft.com/office/drawing/2014/main" id="{19FBE62D-7045-2903-A9AF-B03077C3CB04}"/>
               </a:ext>
             </a:extLst>
           </p:cNvPr>
@@ -15994,7 +15994,7 @@
           <p:cNvPr id="7" name="文本框 6">
             <a:extLst>
               <a:ext uri="{FF2B5EF4-FFF2-40B4-BE49-F238E27FC236}">
-                <a16:creationId xmlns:a16="http://schemas.microsoft.com/office/drawing/2014/main" id="{6B3B9F06-169F-5D2D-7E21-46620C3D6BE9}"/>
+                <a16:creationId xmlns:a16="http://schemas.microsoft.com/office/drawing/2014/main" id="{9B0983F7-219B-01F8-1021-C800DAF66E73}"/>
               </a:ext>
             </a:extLst>
           </p:cNvPr>
@@ -16043,7 +16043,7 @@
           <p:cNvPr id="8" name="矩形: 圆角 7">
             <a:extLst>
               <a:ext uri="{FF2B5EF4-FFF2-40B4-BE49-F238E27FC236}">
-                <a16:creationId xmlns:a16="http://schemas.microsoft.com/office/drawing/2014/main" id="{E991208D-9901-FBBC-1132-D5E2E190B44D}"/>
+                <a16:creationId xmlns:a16="http://schemas.microsoft.com/office/drawing/2014/main" id="{1436165F-C22B-1372-4AE7-8EDA8D12E25A}"/>
               </a:ext>
             </a:extLst>
           </p:cNvPr>
@@ -16111,7 +16111,7 @@
           <p:cNvPr id="9" name="文本框 8">
             <a:extLst>
               <a:ext uri="{FF2B5EF4-FFF2-40B4-BE49-F238E27FC236}">
-                <a16:creationId xmlns:a16="http://schemas.microsoft.com/office/drawing/2014/main" id="{A94445E5-F8C4-B69D-EF12-944E9D1C1E0A}"/>
+                <a16:creationId xmlns:a16="http://schemas.microsoft.com/office/drawing/2014/main" id="{9065B51F-397E-EEE8-082C-5C2C5D06BF8B}"/>
               </a:ext>
             </a:extLst>
           </p:cNvPr>
@@ -16152,7 +16152,7 @@
           <p:cNvPr id="10" name="直接连接符 9">
             <a:extLst>
               <a:ext uri="{FF2B5EF4-FFF2-40B4-BE49-F238E27FC236}">
-                <a16:creationId xmlns:a16="http://schemas.microsoft.com/office/drawing/2014/main" id="{C710D638-AFC0-5D96-C231-C46D248D6457}"/>
+                <a16:creationId xmlns:a16="http://schemas.microsoft.com/office/drawing/2014/main" id="{8777D5B5-ED58-71FE-51EF-6EBAC9A8D41A}"/>
               </a:ext>
             </a:extLst>
           </p:cNvPr>
@@ -16194,7 +16194,7 @@
           <p:cNvPr id="11" name="矩形: 圆角 10">
             <a:extLst>
               <a:ext uri="{FF2B5EF4-FFF2-40B4-BE49-F238E27FC236}">
-                <a16:creationId xmlns:a16="http://schemas.microsoft.com/office/drawing/2014/main" id="{D5FCF9FA-A88D-15C3-5E6E-96BB6D66E69E}"/>
+                <a16:creationId xmlns:a16="http://schemas.microsoft.com/office/drawing/2014/main" id="{34D9443F-0D8F-AEF9-A111-913DAAC0BCEB}"/>
               </a:ext>
             </a:extLst>
           </p:cNvPr>
@@ -16262,7 +16262,7 @@
           <p:cNvPr id="12" name="文本框 11">
             <a:extLst>
               <a:ext uri="{FF2B5EF4-FFF2-40B4-BE49-F238E27FC236}">
-                <a16:creationId xmlns:a16="http://schemas.microsoft.com/office/drawing/2014/main" id="{E0A2809A-6630-B163-7663-8D2CCB04AD94}"/>
+                <a16:creationId xmlns:a16="http://schemas.microsoft.com/office/drawing/2014/main" id="{2C4195DF-6608-F379-024C-4746D7C13CBF}"/>
               </a:ext>
             </a:extLst>
           </p:cNvPr>
@@ -16303,7 +16303,7 @@
           <p:cNvPr id="13" name="直接连接符 12">
             <a:extLst>
               <a:ext uri="{FF2B5EF4-FFF2-40B4-BE49-F238E27FC236}">
-                <a16:creationId xmlns:a16="http://schemas.microsoft.com/office/drawing/2014/main" id="{EEB547B1-F189-4837-5770-7808CB237875}"/>
+                <a16:creationId xmlns:a16="http://schemas.microsoft.com/office/drawing/2014/main" id="{F3F9BD09-EC19-BA02-656D-CB48967E9D70}"/>
               </a:ext>
             </a:extLst>
           </p:cNvPr>
@@ -16345,7 +16345,7 @@
           <p:cNvPr id="14" name="矩形: 圆角 13">
             <a:extLst>
               <a:ext uri="{FF2B5EF4-FFF2-40B4-BE49-F238E27FC236}">
-                <a16:creationId xmlns:a16="http://schemas.microsoft.com/office/drawing/2014/main" id="{C39905EE-DA35-8B1E-E2D8-1DBA4AC37579}"/>
+                <a16:creationId xmlns:a16="http://schemas.microsoft.com/office/drawing/2014/main" id="{8A84EB3E-98AE-5DE2-233A-4E8C2FE152F9}"/>
               </a:ext>
             </a:extLst>
           </p:cNvPr>
@@ -16413,7 +16413,7 @@
           <p:cNvPr id="15" name="文本框 14">
             <a:extLst>
               <a:ext uri="{FF2B5EF4-FFF2-40B4-BE49-F238E27FC236}">
-                <a16:creationId xmlns:a16="http://schemas.microsoft.com/office/drawing/2014/main" id="{FE82F404-0EA5-BA50-4AF3-FAEF1EE06413}"/>
+                <a16:creationId xmlns:a16="http://schemas.microsoft.com/office/drawing/2014/main" id="{E5C766C1-F919-0FD1-C150-78769189149E}"/>
               </a:ext>
             </a:extLst>
           </p:cNvPr>
@@ -16471,7 +16471,7 @@
           <p:cNvPr id="16" name="文本框 15">
             <a:extLst>
               <a:ext uri="{FF2B5EF4-FFF2-40B4-BE49-F238E27FC236}">
-                <a16:creationId xmlns:a16="http://schemas.microsoft.com/office/drawing/2014/main" id="{3ADC51E6-34D4-A48C-A7CE-34480DF168A7}"/>
+                <a16:creationId xmlns:a16="http://schemas.microsoft.com/office/drawing/2014/main" id="{444D8B69-885E-F899-99DC-DC6130043061}"/>
               </a:ext>
             </a:extLst>
           </p:cNvPr>
@@ -16512,7 +16512,7 @@
           <p:cNvPr id="17" name="文本框 16">
             <a:extLst>
               <a:ext uri="{FF2B5EF4-FFF2-40B4-BE49-F238E27FC236}">
-                <a16:creationId xmlns:a16="http://schemas.microsoft.com/office/drawing/2014/main" id="{B762591F-9533-F09C-1695-D3838FAEA5A0}"/>
+                <a16:creationId xmlns:a16="http://schemas.microsoft.com/office/drawing/2014/main" id="{A109EC10-0122-CF4E-971A-8DDB8ADFD8BB}"/>
               </a:ext>
             </a:extLst>
           </p:cNvPr>
@@ -16560,7 +16560,7 @@
           <p:cNvPr id="18" name="文本框 17">
             <a:extLst>
               <a:ext uri="{FF2B5EF4-FFF2-40B4-BE49-F238E27FC236}">
-                <a16:creationId xmlns:a16="http://schemas.microsoft.com/office/drawing/2014/main" id="{B0B034B4-7A03-6B94-5241-9C457552D7CF}"/>
+                <a16:creationId xmlns:a16="http://schemas.microsoft.com/office/drawing/2014/main" id="{45566EAC-909F-579F-E81D-EEC157F12BF5}"/>
               </a:ext>
             </a:extLst>
           </p:cNvPr>
@@ -16602,7 +16602,7 @@
           <p:cNvPr id="19" name="直接连接符 18">
             <a:extLst>
               <a:ext uri="{FF2B5EF4-FFF2-40B4-BE49-F238E27FC236}">
-                <a16:creationId xmlns:a16="http://schemas.microsoft.com/office/drawing/2014/main" id="{B5480CDE-9B91-F92C-9A68-AEEC3A092A14}"/>
+                <a16:creationId xmlns:a16="http://schemas.microsoft.com/office/drawing/2014/main" id="{BB648B8F-57FE-CF02-F0DD-250B6B93260A}"/>
               </a:ext>
             </a:extLst>
           </p:cNvPr>
@@ -16643,7 +16643,7 @@
           <p:cNvPr id="20" name="文本框 19">
             <a:extLst>
               <a:ext uri="{FF2B5EF4-FFF2-40B4-BE49-F238E27FC236}">
-                <a16:creationId xmlns:a16="http://schemas.microsoft.com/office/drawing/2014/main" id="{3C1A92A9-992E-2FAE-978B-DD2C2D44F630}"/>
+                <a16:creationId xmlns:a16="http://schemas.microsoft.com/office/drawing/2014/main" id="{B8B95845-FF8A-23C6-8B94-F30AB43965D8}"/>
               </a:ext>
             </a:extLst>
           </p:cNvPr>
@@ -16684,7 +16684,7 @@
           <p:cNvPr id="21" name="文本框 20">
             <a:extLst>
               <a:ext uri="{FF2B5EF4-FFF2-40B4-BE49-F238E27FC236}">
-                <a16:creationId xmlns:a16="http://schemas.microsoft.com/office/drawing/2014/main" id="{033EB728-6A42-0A40-2A9A-757E7F1AB6C9}"/>
+                <a16:creationId xmlns:a16="http://schemas.microsoft.com/office/drawing/2014/main" id="{1BE56D51-0112-E89B-EE8B-93F9CEA0B14C}"/>
               </a:ext>
             </a:extLst>
           </p:cNvPr>
@@ -16808,7 +16808,7 @@
           <p:cNvPr id="22" name="矩形 21">
             <a:extLst>
               <a:ext uri="{FF2B5EF4-FFF2-40B4-BE49-F238E27FC236}">
-                <a16:creationId xmlns:a16="http://schemas.microsoft.com/office/drawing/2014/main" id="{088C73B2-6C0D-0FD8-5A1E-2B76EC6443F1}"/>
+                <a16:creationId xmlns:a16="http://schemas.microsoft.com/office/drawing/2014/main" id="{645975D5-B534-108E-7E57-4DCA0A2FB4B0}"/>
               </a:ext>
             </a:extLst>
           </p:cNvPr>
@@ -16876,7 +16876,7 @@
           <p:cNvPr id="23" name="文本框 22">
             <a:extLst>
               <a:ext uri="{FF2B5EF4-FFF2-40B4-BE49-F238E27FC236}">
-                <a16:creationId xmlns:a16="http://schemas.microsoft.com/office/drawing/2014/main" id="{4237A967-1B56-AB50-88DE-87D46027818F}"/>
+                <a16:creationId xmlns:a16="http://schemas.microsoft.com/office/drawing/2014/main" id="{323D0E14-7D51-A14C-7520-B57DFD868009}"/>
               </a:ext>
             </a:extLst>
           </p:cNvPr>
@@ -16957,7 +16957,7 @@
           <p:cNvPr id="24" name="直接连接符 23">
             <a:extLst>
               <a:ext uri="{FF2B5EF4-FFF2-40B4-BE49-F238E27FC236}">
-                <a16:creationId xmlns:a16="http://schemas.microsoft.com/office/drawing/2014/main" id="{A6D2253C-0234-4FF3-343D-FF76BF4FBC20}"/>
+                <a16:creationId xmlns:a16="http://schemas.microsoft.com/office/drawing/2014/main" id="{CD163D7E-51B1-5FCB-B92C-F8AAA50D109C}"/>
               </a:ext>
             </a:extLst>
           </p:cNvPr>
@@ -16999,7 +16999,7 @@
             <a:hlinkClick r:id="rId3"/>
             <a:extLst>
               <a:ext uri="{FF2B5EF4-FFF2-40B4-BE49-F238E27FC236}">
-                <a16:creationId xmlns:a16="http://schemas.microsoft.com/office/drawing/2014/main" id="{59846B17-781D-4C5D-DDAE-BFA6E574CBBF}"/>
+                <a16:creationId xmlns:a16="http://schemas.microsoft.com/office/drawing/2014/main" id="{9714ABAE-B5B0-6060-D03B-F38E710F904E}"/>
               </a:ext>
             </a:extLst>
           </p:cNvPr>
@@ -17078,7 +17078,7 @@
     </p:spTree>
     <p:extLst>
       <p:ext uri="{BB962C8B-B14F-4D97-AF65-F5344CB8AC3E}">
-        <p14:creationId xmlns:p14="http://schemas.microsoft.com/office/powerpoint/2010/main" val="3492815968"/>
+        <p14:creationId xmlns:p14="http://schemas.microsoft.com/office/powerpoint/2010/main" val="1065858520"/>
       </p:ext>
     </p:extLst>
   </p:cSld>

</xml_diff>